<commit_message>
Fix logging and add autto remove name from homepage when user apid
</commit_message>
<xml_diff>
--- a/E-Viotrack.pptx
+++ b/E-Viotrack.pptx
@@ -7,6 +7,7 @@
   <p:sldIdLst>
     <p:sldId id="256" r:id="rId2"/>
     <p:sldId id="258" r:id="rId3"/>
+    <p:sldId id="259" r:id="rId4"/>
   </p:sldIdLst>
   <p:sldSz cx="12192000" cy="6858000"/>
   <p:notesSz cx="6858000" cy="9144000"/>
@@ -105,6 +106,11 @@
       </a:defRPr>
     </a:lvl9pPr>
   </p:defaultTextStyle>
+  <p:extLst>
+    <p:ext uri="{EFAFB233-063F-42B5-8137-9DF3F51BA10A}">
+      <p15:sldGuideLst xmlns:p15="http://schemas.microsoft.com/office/powerpoint/2012/main"/>
+    </p:ext>
+  </p:extLst>
 </p:presentation>
 </file>
 
@@ -255,7 +261,7 @@
           <a:p>
             <a:fld id="{6316C218-4004-4F87-AB00-2790D8F09C66}" type="datetimeFigureOut">
               <a:rPr lang="en-US" smtClean="0"/>
-              <a:t>2/8/2026</a:t>
+              <a:t>2/21/2026</a:t>
             </a:fld>
             <a:endParaRPr lang="en-US"/>
           </a:p>
@@ -453,7 +459,7 @@
           <a:p>
             <a:fld id="{6316C218-4004-4F87-AB00-2790D8F09C66}" type="datetimeFigureOut">
               <a:rPr lang="en-US" smtClean="0"/>
-              <a:t>2/8/2026</a:t>
+              <a:t>2/21/2026</a:t>
             </a:fld>
             <a:endParaRPr lang="en-US"/>
           </a:p>
@@ -661,7 +667,7 @@
           <a:p>
             <a:fld id="{6316C218-4004-4F87-AB00-2790D8F09C66}" type="datetimeFigureOut">
               <a:rPr lang="en-US" smtClean="0"/>
-              <a:t>2/8/2026</a:t>
+              <a:t>2/21/2026</a:t>
             </a:fld>
             <a:endParaRPr lang="en-US"/>
           </a:p>
@@ -859,7 +865,7 @@
           <a:p>
             <a:fld id="{6316C218-4004-4F87-AB00-2790D8F09C66}" type="datetimeFigureOut">
               <a:rPr lang="en-US" smtClean="0"/>
-              <a:t>2/8/2026</a:t>
+              <a:t>2/21/2026</a:t>
             </a:fld>
             <a:endParaRPr lang="en-US"/>
           </a:p>
@@ -1134,7 +1140,7 @@
           <a:p>
             <a:fld id="{6316C218-4004-4F87-AB00-2790D8F09C66}" type="datetimeFigureOut">
               <a:rPr lang="en-US" smtClean="0"/>
-              <a:t>2/8/2026</a:t>
+              <a:t>2/21/2026</a:t>
             </a:fld>
             <a:endParaRPr lang="en-US"/>
           </a:p>
@@ -1399,7 +1405,7 @@
           <a:p>
             <a:fld id="{6316C218-4004-4F87-AB00-2790D8F09C66}" type="datetimeFigureOut">
               <a:rPr lang="en-US" smtClean="0"/>
-              <a:t>2/8/2026</a:t>
+              <a:t>2/21/2026</a:t>
             </a:fld>
             <a:endParaRPr lang="en-US"/>
           </a:p>
@@ -1811,7 +1817,7 @@
           <a:p>
             <a:fld id="{6316C218-4004-4F87-AB00-2790D8F09C66}" type="datetimeFigureOut">
               <a:rPr lang="en-US" smtClean="0"/>
-              <a:t>2/8/2026</a:t>
+              <a:t>2/21/2026</a:t>
             </a:fld>
             <a:endParaRPr lang="en-US"/>
           </a:p>
@@ -1952,7 +1958,7 @@
           <a:p>
             <a:fld id="{6316C218-4004-4F87-AB00-2790D8F09C66}" type="datetimeFigureOut">
               <a:rPr lang="en-US" smtClean="0"/>
-              <a:t>2/8/2026</a:t>
+              <a:t>2/21/2026</a:t>
             </a:fld>
             <a:endParaRPr lang="en-US"/>
           </a:p>
@@ -2065,7 +2071,7 @@
           <a:p>
             <a:fld id="{6316C218-4004-4F87-AB00-2790D8F09C66}" type="datetimeFigureOut">
               <a:rPr lang="en-US" smtClean="0"/>
-              <a:t>2/8/2026</a:t>
+              <a:t>2/21/2026</a:t>
             </a:fld>
             <a:endParaRPr lang="en-US"/>
           </a:p>
@@ -2376,7 +2382,7 @@
           <a:p>
             <a:fld id="{6316C218-4004-4F87-AB00-2790D8F09C66}" type="datetimeFigureOut">
               <a:rPr lang="en-US" smtClean="0"/>
-              <a:t>2/8/2026</a:t>
+              <a:t>2/21/2026</a:t>
             </a:fld>
             <a:endParaRPr lang="en-US"/>
           </a:p>
@@ -2664,7 +2670,7 @@
           <a:p>
             <a:fld id="{6316C218-4004-4F87-AB00-2790D8F09C66}" type="datetimeFigureOut">
               <a:rPr lang="en-US" smtClean="0"/>
-              <a:t>2/8/2026</a:t>
+              <a:t>2/21/2026</a:t>
             </a:fld>
             <a:endParaRPr lang="en-US"/>
           </a:p>
@@ -2905,7 +2911,7 @@
           <a:p>
             <a:fld id="{6316C218-4004-4F87-AB00-2790D8F09C66}" type="datetimeFigureOut">
               <a:rPr lang="en-US" smtClean="0"/>
-              <a:t>2/8/2026</a:t>
+              <a:t>2/21/2026</a:t>
             </a:fld>
             <a:endParaRPr lang="en-US"/>
           </a:p>
@@ -3416,10 +3422,316 @@
           <a:chExt cx="0" cy="0"/>
         </a:xfrm>
       </p:grpSpPr>
+      <p:pic>
+        <p:nvPicPr>
+          <p:cNvPr id="2" name="Picture 1">
+            <a:extLst>
+              <a:ext uri="{FF2B5EF4-FFF2-40B4-BE49-F238E27FC236}">
+                <a16:creationId xmlns:a16="http://schemas.microsoft.com/office/drawing/2014/main" id="{444CD949-FC82-0A54-31F8-2717CC9EC313}"/>
+              </a:ext>
+            </a:extLst>
+          </p:cNvPr>
+          <p:cNvPicPr>
+            <a:picLocks noChangeAspect="1"/>
+          </p:cNvPicPr>
+          <p:nvPr/>
+        </p:nvPicPr>
+        <p:blipFill>
+          <a:blip r:embed="rId2">
+            <a:extLst>
+              <a:ext uri="{28A0092B-C50C-407E-A947-70E740481C1C}">
+                <a14:useLocalDpi xmlns:a14="http://schemas.microsoft.com/office/drawing/2010/main" val="0"/>
+              </a:ext>
+            </a:extLst>
+          </a:blip>
+          <a:stretch>
+            <a:fillRect/>
+          </a:stretch>
+        </p:blipFill>
+        <p:spPr>
+          <a:xfrm>
+            <a:off x="475488" y="429767"/>
+            <a:ext cx="2772802" cy="1563625"/>
+          </a:xfrm>
+          <a:prstGeom prst="rect">
+            <a:avLst/>
+          </a:prstGeom>
+        </p:spPr>
+      </p:pic>
+      <p:sp>
+        <p:nvSpPr>
+          <p:cNvPr id="3" name="TextBox 2">
+            <a:extLst>
+              <a:ext uri="{FF2B5EF4-FFF2-40B4-BE49-F238E27FC236}">
+                <a16:creationId xmlns:a16="http://schemas.microsoft.com/office/drawing/2014/main" id="{35920162-4883-EA9C-013B-7AED4A2B75FB}"/>
+              </a:ext>
+            </a:extLst>
+          </p:cNvPr>
+          <p:cNvSpPr txBox="1"/>
+          <p:nvPr/>
+        </p:nvSpPr>
+        <p:spPr>
+          <a:xfrm>
+            <a:off x="868680" y="2478024"/>
+            <a:ext cx="10981944" cy="923330"/>
+          </a:xfrm>
+          <a:prstGeom prst="rect">
+            <a:avLst/>
+          </a:prstGeom>
+          <a:noFill/>
+        </p:spPr>
+        <p:txBody>
+          <a:bodyPr wrap="square" rtlCol="0">
+            <a:spAutoFit/>
+          </a:bodyPr>
+          <a:lstStyle/>
+          <a:p>
+            <a:r>
+              <a:rPr lang="en-US" dirty="0"/>
+              <a:t>E-</a:t>
+            </a:r>
+            <a:r>
+              <a:rPr lang="en-US" dirty="0" err="1"/>
+              <a:t>Viotrack</a:t>
+            </a:r>
+            <a:r>
+              <a:rPr lang="en-US" dirty="0"/>
+              <a:t> is a desktop application for managing RFID-based vehicle tracking and violation management. It interfaces with long-range RFID readers via serial connection, validates scanned RFID tags against a local SQLite database, and displays real-time violation information for drivers.</a:t>
+            </a:r>
+          </a:p>
+        </p:txBody>
+      </p:sp>
+      <p:sp>
+        <p:nvSpPr>
+          <p:cNvPr id="4" name="TextBox 3">
+            <a:extLst>
+              <a:ext uri="{FF2B5EF4-FFF2-40B4-BE49-F238E27FC236}">
+                <a16:creationId xmlns:a16="http://schemas.microsoft.com/office/drawing/2014/main" id="{1A7A52EF-6F29-1C6A-B362-70801E88D856}"/>
+              </a:ext>
+            </a:extLst>
+          </p:cNvPr>
+          <p:cNvSpPr txBox="1"/>
+          <p:nvPr/>
+        </p:nvSpPr>
+        <p:spPr>
+          <a:xfrm>
+            <a:off x="868680" y="3885986"/>
+            <a:ext cx="10981944" cy="1754326"/>
+          </a:xfrm>
+          <a:prstGeom prst="rect">
+            <a:avLst/>
+          </a:prstGeom>
+          <a:noFill/>
+        </p:spPr>
+        <p:txBody>
+          <a:bodyPr wrap="square" rtlCol="0">
+            <a:spAutoFit/>
+          </a:bodyPr>
+          <a:lstStyle/>
+          <a:p>
+            <a:r>
+              <a:rPr lang="en-US" b="1" dirty="0"/>
+              <a:t>Overview</a:t>
+            </a:r>
+          </a:p>
+          <a:p>
+            <a:r>
+              <a:rPr lang="en-US" dirty="0"/>
+              <a:t>The system reads RFID tag IDs from long-range RFID hardware and queries a database to retrieve associated driver information and any active unpaid violations. Results are displayed immediately in an intuitive GUI based on PyQt6.</a:t>
+            </a:r>
+          </a:p>
+          <a:p>
+            <a:br>
+              <a:rPr lang="en-US" dirty="0"/>
+            </a:br>
+            <a:endParaRPr lang="en-US" dirty="0"/>
+          </a:p>
+        </p:txBody>
+      </p:sp>
     </p:spTree>
     <p:extLst>
       <p:ext uri="{BB962C8B-B14F-4D97-AF65-F5344CB8AC3E}">
         <p14:creationId xmlns:p14="http://schemas.microsoft.com/office/powerpoint/2010/main" val="1151521904"/>
+      </p:ext>
+    </p:extLst>
+  </p:cSld>
+  <p:clrMapOvr>
+    <a:masterClrMapping/>
+  </p:clrMapOvr>
+</p:sld>
+</file>
+
+<file path=ppt/slides/slide3.xml><?xml version="1.0" encoding="utf-8"?>
+<p:sld xmlns:a="http://schemas.openxmlformats.org/drawingml/2006/main" xmlns:r="http://schemas.openxmlformats.org/officeDocument/2006/relationships" xmlns:p="http://schemas.openxmlformats.org/presentationml/2006/main">
+  <p:cSld>
+    <p:spTree>
+      <p:nvGrpSpPr>
+        <p:cNvPr id="1" name=""/>
+        <p:cNvGrpSpPr/>
+        <p:nvPr/>
+      </p:nvGrpSpPr>
+      <p:grpSpPr>
+        <a:xfrm>
+          <a:off x="0" y="0"/>
+          <a:ext cx="0" cy="0"/>
+          <a:chOff x="0" y="0"/>
+          <a:chExt cx="0" cy="0"/>
+        </a:xfrm>
+      </p:grpSpPr>
+      <p:sp>
+        <p:nvSpPr>
+          <p:cNvPr id="4" name="TextBox 3">
+            <a:extLst>
+              <a:ext uri="{FF2B5EF4-FFF2-40B4-BE49-F238E27FC236}">
+                <a16:creationId xmlns:a16="http://schemas.microsoft.com/office/drawing/2014/main" id="{CCE1AC6C-5C55-A4B1-42FB-7907BE1F424D}"/>
+              </a:ext>
+            </a:extLst>
+          </p:cNvPr>
+          <p:cNvSpPr txBox="1"/>
+          <p:nvPr/>
+        </p:nvSpPr>
+        <p:spPr>
+          <a:xfrm>
+            <a:off x="960120" y="987552"/>
+            <a:ext cx="10506456" cy="2369880"/>
+          </a:xfrm>
+          <a:prstGeom prst="rect">
+            <a:avLst/>
+          </a:prstGeom>
+          <a:noFill/>
+        </p:spPr>
+        <p:txBody>
+          <a:bodyPr wrap="square" rtlCol="0">
+            <a:spAutoFit/>
+          </a:bodyPr>
+          <a:lstStyle/>
+          <a:p>
+            <a:r>
+              <a:rPr lang="en-US" b="1" dirty="0"/>
+              <a:t>Features</a:t>
+            </a:r>
+          </a:p>
+          <a:p>
+            <a:pPr marL="285750" indent="-285750">
+              <a:buFont typeface="Arial" panose="020B0604020202020204" pitchFamily="34" charset="0"/>
+              <a:buChar char="•"/>
+            </a:pPr>
+            <a:r>
+              <a:rPr lang="en-US" sz="1400" b="1" dirty="0"/>
+              <a:t>RFID Tag Reading</a:t>
+            </a:r>
+            <a:r>
+              <a:rPr lang="en-US" sz="1400" dirty="0"/>
+              <a:t>: Connects to long-range RFID readers via RS232/USB serial connection</a:t>
+            </a:r>
+          </a:p>
+          <a:p>
+            <a:pPr marL="285750" indent="-285750">
+              <a:buFont typeface="Arial" panose="020B0604020202020204" pitchFamily="34" charset="0"/>
+              <a:buChar char="•"/>
+            </a:pPr>
+            <a:r>
+              <a:rPr lang="en-US" sz="1400" b="1" dirty="0"/>
+              <a:t>Real-time Validation</a:t>
+            </a:r>
+            <a:r>
+              <a:rPr lang="en-US" sz="1400" dirty="0"/>
+              <a:t>: Instantly checks driver records and violation status in SQLite database</a:t>
+            </a:r>
+          </a:p>
+          <a:p>
+            <a:pPr marL="285750" indent="-285750">
+              <a:buFont typeface="Arial" panose="020B0604020202020204" pitchFamily="34" charset="0"/>
+              <a:buChar char="•"/>
+            </a:pPr>
+            <a:r>
+              <a:rPr lang="en-US" sz="1400" b="1" dirty="0"/>
+              <a:t>Violation Tracking</a:t>
+            </a:r>
+            <a:r>
+              <a:rPr lang="en-US" sz="1400" dirty="0"/>
+              <a:t>: Detects and displays active unpaid violations for scanned drivers</a:t>
+            </a:r>
+          </a:p>
+          <a:p>
+            <a:pPr marL="285750" indent="-285750">
+              <a:buFont typeface="Arial" panose="020B0604020202020204" pitchFamily="34" charset="0"/>
+              <a:buChar char="•"/>
+            </a:pPr>
+            <a:r>
+              <a:rPr lang="en-US" sz="1400" b="1" dirty="0"/>
+              <a:t>Driver Management</a:t>
+            </a:r>
+            <a:r>
+              <a:rPr lang="en-US" sz="1400" dirty="0"/>
+              <a:t>: Edit driver profiles, violation records, and violation types</a:t>
+            </a:r>
+          </a:p>
+          <a:p>
+            <a:pPr marL="285750" indent="-285750">
+              <a:buFont typeface="Arial" panose="020B0604020202020204" pitchFamily="34" charset="0"/>
+              <a:buChar char="•"/>
+            </a:pPr>
+            <a:r>
+              <a:rPr lang="en-US" sz="1400" b="1" dirty="0"/>
+              <a:t>Activity Logging</a:t>
+            </a:r>
+            <a:r>
+              <a:rPr lang="en-US" sz="1400" dirty="0"/>
+              <a:t>: Comprehensive logging of all scan activities and system events</a:t>
+            </a:r>
+          </a:p>
+          <a:p>
+            <a:pPr marL="285750" indent="-285750">
+              <a:buFont typeface="Arial" panose="020B0604020202020204" pitchFamily="34" charset="0"/>
+              <a:buChar char="•"/>
+            </a:pPr>
+            <a:r>
+              <a:rPr lang="en-US" sz="1400" b="1" dirty="0"/>
+              <a:t>User-Friendly GUI</a:t>
+            </a:r>
+            <a:r>
+              <a:rPr lang="en-US" sz="1400" dirty="0"/>
+              <a:t>: Modern PyQt6-based interface with animated transitions</a:t>
+            </a:r>
+          </a:p>
+          <a:p>
+            <a:pPr marL="285750" indent="-285750">
+              <a:buFont typeface="Arial" panose="020B0604020202020204" pitchFamily="34" charset="0"/>
+              <a:buChar char="•"/>
+            </a:pPr>
+            <a:r>
+              <a:rPr lang="en-US" sz="1400" b="1" dirty="0"/>
+              <a:t>Settings Management</a:t>
+            </a:r>
+            <a:r>
+              <a:rPr lang="en-US" sz="1400" dirty="0"/>
+              <a:t>: Configure RFID reader parameters and application behavior</a:t>
+            </a:r>
+          </a:p>
+          <a:p>
+            <a:pPr marL="285750" indent="-285750">
+              <a:buFont typeface="Arial" panose="020B0604020202020204" pitchFamily="34" charset="0"/>
+              <a:buChar char="•"/>
+            </a:pPr>
+            <a:r>
+              <a:rPr lang="en-US" sz="1400" b="1" dirty="0"/>
+              <a:t>Admin Panel</a:t>
+            </a:r>
+            <a:r>
+              <a:rPr lang="en-US" sz="1400" dirty="0"/>
+              <a:t>: Administrative interface for user and violation management</a:t>
+            </a:r>
+          </a:p>
+          <a:p>
+            <a:endParaRPr lang="en-US" dirty="0"/>
+          </a:p>
+        </p:txBody>
+      </p:sp>
+    </p:spTree>
+    <p:extLst>
+      <p:ext uri="{BB962C8B-B14F-4D97-AF65-F5344CB8AC3E}">
+        <p14:creationId xmlns:p14="http://schemas.microsoft.com/office/powerpoint/2010/main" val="2607787864"/>
       </p:ext>
     </p:extLst>
   </p:cSld>

</xml_diff>

<commit_message>
update ReadMe.md and Documentation
</commit_message>
<xml_diff>
--- a/E-Viotrack.pptx
+++ b/E-Viotrack.pptx
@@ -4,10 +4,19 @@
   <p:sldMasterIdLst>
     <p:sldMasterId id="2147483648" r:id="rId1"/>
   </p:sldMasterIdLst>
+  <p:notesMasterIdLst>
+    <p:notesMasterId r:id="rId11"/>
+  </p:notesMasterIdLst>
   <p:sldIdLst>
     <p:sldId id="256" r:id="rId2"/>
     <p:sldId id="258" r:id="rId3"/>
     <p:sldId id="259" r:id="rId4"/>
+    <p:sldId id="260" r:id="rId5"/>
+    <p:sldId id="261" r:id="rId6"/>
+    <p:sldId id="263" r:id="rId7"/>
+    <p:sldId id="264" r:id="rId8"/>
+    <p:sldId id="265" r:id="rId9"/>
+    <p:sldId id="266" r:id="rId10"/>
   </p:sldIdLst>
   <p:sldSz cx="12192000" cy="6858000"/>
   <p:notesSz cx="6858000" cy="9144000"/>
@@ -114,6 +123,439 @@
 </p:presentation>
 </file>
 
+<file path=ppt/notesMasters/notesMaster1.xml><?xml version="1.0" encoding="utf-8"?>
+<p:notesMaster xmlns:a="http://schemas.openxmlformats.org/drawingml/2006/main" xmlns:r="http://schemas.openxmlformats.org/officeDocument/2006/relationships" xmlns:p="http://schemas.openxmlformats.org/presentationml/2006/main">
+  <p:cSld>
+    <p:bg>
+      <p:bgRef idx="1001">
+        <a:schemeClr val="bg1"/>
+      </p:bgRef>
+    </p:bg>
+    <p:spTree>
+      <p:nvGrpSpPr>
+        <p:cNvPr id="1" name=""/>
+        <p:cNvGrpSpPr/>
+        <p:nvPr/>
+      </p:nvGrpSpPr>
+      <p:grpSpPr>
+        <a:xfrm>
+          <a:off x="0" y="0"/>
+          <a:ext cx="0" cy="0"/>
+          <a:chOff x="0" y="0"/>
+          <a:chExt cx="0" cy="0"/>
+        </a:xfrm>
+      </p:grpSpPr>
+      <p:sp>
+        <p:nvSpPr>
+          <p:cNvPr id="2" name="Header Placeholder 1"/>
+          <p:cNvSpPr>
+            <a:spLocks noGrp="1"/>
+          </p:cNvSpPr>
+          <p:nvPr>
+            <p:ph type="hdr" sz="quarter"/>
+          </p:nvPr>
+        </p:nvSpPr>
+        <p:spPr>
+          <a:xfrm>
+            <a:off x="0" y="0"/>
+            <a:ext cx="2971800" cy="458788"/>
+          </a:xfrm>
+          <a:prstGeom prst="rect">
+            <a:avLst/>
+          </a:prstGeom>
+        </p:spPr>
+        <p:txBody>
+          <a:bodyPr vert="horz" lIns="91440" tIns="45720" rIns="91440" bIns="45720" rtlCol="0"/>
+          <a:lstStyle>
+            <a:lvl1pPr algn="l">
+              <a:defRPr sz="1200"/>
+            </a:lvl1pPr>
+          </a:lstStyle>
+          <a:p>
+            <a:endParaRPr lang="en-US"/>
+          </a:p>
+        </p:txBody>
+      </p:sp>
+      <p:sp>
+        <p:nvSpPr>
+          <p:cNvPr id="3" name="Date Placeholder 2"/>
+          <p:cNvSpPr>
+            <a:spLocks noGrp="1"/>
+          </p:cNvSpPr>
+          <p:nvPr>
+            <p:ph type="dt" idx="1"/>
+          </p:nvPr>
+        </p:nvSpPr>
+        <p:spPr>
+          <a:xfrm>
+            <a:off x="3884613" y="0"/>
+            <a:ext cx="2971800" cy="458788"/>
+          </a:xfrm>
+          <a:prstGeom prst="rect">
+            <a:avLst/>
+          </a:prstGeom>
+        </p:spPr>
+        <p:txBody>
+          <a:bodyPr vert="horz" lIns="91440" tIns="45720" rIns="91440" bIns="45720" rtlCol="0"/>
+          <a:lstStyle>
+            <a:lvl1pPr algn="r">
+              <a:defRPr sz="1200"/>
+            </a:lvl1pPr>
+          </a:lstStyle>
+          <a:p>
+            <a:fld id="{06893496-D802-427B-87C3-EB2AF557B1B5}" type="datetimeFigureOut">
+              <a:rPr lang="en-US" smtClean="0"/>
+              <a:t>2/23/2026</a:t>
+            </a:fld>
+            <a:endParaRPr lang="en-US"/>
+          </a:p>
+        </p:txBody>
+      </p:sp>
+      <p:sp>
+        <p:nvSpPr>
+          <p:cNvPr id="4" name="Slide Image Placeholder 3"/>
+          <p:cNvSpPr>
+            <a:spLocks noGrp="1" noRot="1" noChangeAspect="1"/>
+          </p:cNvSpPr>
+          <p:nvPr>
+            <p:ph type="sldImg" idx="2"/>
+          </p:nvPr>
+        </p:nvSpPr>
+        <p:spPr>
+          <a:xfrm>
+            <a:off x="685800" y="1143000"/>
+            <a:ext cx="5486400" cy="3086100"/>
+          </a:xfrm>
+          <a:prstGeom prst="rect">
+            <a:avLst/>
+          </a:prstGeom>
+          <a:noFill/>
+          <a:ln w="12700">
+            <a:solidFill>
+              <a:prstClr val="black"/>
+            </a:solidFill>
+          </a:ln>
+        </p:spPr>
+        <p:txBody>
+          <a:bodyPr vert="horz" lIns="91440" tIns="45720" rIns="91440" bIns="45720" rtlCol="0" anchor="ctr"/>
+          <a:lstStyle/>
+          <a:p>
+            <a:endParaRPr lang="en-US"/>
+          </a:p>
+        </p:txBody>
+      </p:sp>
+      <p:sp>
+        <p:nvSpPr>
+          <p:cNvPr id="5" name="Notes Placeholder 4"/>
+          <p:cNvSpPr>
+            <a:spLocks noGrp="1"/>
+          </p:cNvSpPr>
+          <p:nvPr>
+            <p:ph type="body" sz="quarter" idx="3"/>
+          </p:nvPr>
+        </p:nvSpPr>
+        <p:spPr>
+          <a:xfrm>
+            <a:off x="685800" y="4400550"/>
+            <a:ext cx="5486400" cy="3600450"/>
+          </a:xfrm>
+          <a:prstGeom prst="rect">
+            <a:avLst/>
+          </a:prstGeom>
+        </p:spPr>
+        <p:txBody>
+          <a:bodyPr vert="horz" lIns="91440" tIns="45720" rIns="91440" bIns="45720" rtlCol="0"/>
+          <a:lstStyle/>
+          <a:p>
+            <a:pPr lvl="0"/>
+            <a:r>
+              <a:rPr lang="en-US"/>
+              <a:t>Click to edit Master text styles</a:t>
+            </a:r>
+          </a:p>
+          <a:p>
+            <a:pPr lvl="1"/>
+            <a:r>
+              <a:rPr lang="en-US"/>
+              <a:t>Second level</a:t>
+            </a:r>
+          </a:p>
+          <a:p>
+            <a:pPr lvl="2"/>
+            <a:r>
+              <a:rPr lang="en-US"/>
+              <a:t>Third level</a:t>
+            </a:r>
+          </a:p>
+          <a:p>
+            <a:pPr lvl="3"/>
+            <a:r>
+              <a:rPr lang="en-US"/>
+              <a:t>Fourth level</a:t>
+            </a:r>
+          </a:p>
+          <a:p>
+            <a:pPr lvl="4"/>
+            <a:r>
+              <a:rPr lang="en-US"/>
+              <a:t>Fifth level</a:t>
+            </a:r>
+          </a:p>
+        </p:txBody>
+      </p:sp>
+      <p:sp>
+        <p:nvSpPr>
+          <p:cNvPr id="6" name="Footer Placeholder 5"/>
+          <p:cNvSpPr>
+            <a:spLocks noGrp="1"/>
+          </p:cNvSpPr>
+          <p:nvPr>
+            <p:ph type="ftr" sz="quarter" idx="4"/>
+          </p:nvPr>
+        </p:nvSpPr>
+        <p:spPr>
+          <a:xfrm>
+            <a:off x="0" y="8685213"/>
+            <a:ext cx="2971800" cy="458787"/>
+          </a:xfrm>
+          <a:prstGeom prst="rect">
+            <a:avLst/>
+          </a:prstGeom>
+        </p:spPr>
+        <p:txBody>
+          <a:bodyPr vert="horz" lIns="91440" tIns="45720" rIns="91440" bIns="45720" rtlCol="0" anchor="b"/>
+          <a:lstStyle>
+            <a:lvl1pPr algn="l">
+              <a:defRPr sz="1200"/>
+            </a:lvl1pPr>
+          </a:lstStyle>
+          <a:p>
+            <a:endParaRPr lang="en-US"/>
+          </a:p>
+        </p:txBody>
+      </p:sp>
+      <p:sp>
+        <p:nvSpPr>
+          <p:cNvPr id="7" name="Slide Number Placeholder 6"/>
+          <p:cNvSpPr>
+            <a:spLocks noGrp="1"/>
+          </p:cNvSpPr>
+          <p:nvPr>
+            <p:ph type="sldNum" sz="quarter" idx="5"/>
+          </p:nvPr>
+        </p:nvSpPr>
+        <p:spPr>
+          <a:xfrm>
+            <a:off x="3884613" y="8685213"/>
+            <a:ext cx="2971800" cy="458787"/>
+          </a:xfrm>
+          <a:prstGeom prst="rect">
+            <a:avLst/>
+          </a:prstGeom>
+        </p:spPr>
+        <p:txBody>
+          <a:bodyPr vert="horz" lIns="91440" tIns="45720" rIns="91440" bIns="45720" rtlCol="0" anchor="b"/>
+          <a:lstStyle>
+            <a:lvl1pPr algn="r">
+              <a:defRPr sz="1200"/>
+            </a:lvl1pPr>
+          </a:lstStyle>
+          <a:p>
+            <a:fld id="{96A30439-D87D-4C5C-ACC1-25E9A515DBC1}" type="slidenum">
+              <a:rPr lang="en-US" smtClean="0"/>
+              <a:t>‹#›</a:t>
+            </a:fld>
+            <a:endParaRPr lang="en-US"/>
+          </a:p>
+        </p:txBody>
+      </p:sp>
+    </p:spTree>
+    <p:extLst>
+      <p:ext uri="{BB962C8B-B14F-4D97-AF65-F5344CB8AC3E}">
+        <p14:creationId xmlns:p14="http://schemas.microsoft.com/office/powerpoint/2010/main" val="1635419984"/>
+      </p:ext>
+    </p:extLst>
+  </p:cSld>
+  <p:clrMap bg1="lt1" tx1="dk1" bg2="lt2" tx2="dk2" accent1="accent1" accent2="accent2" accent3="accent3" accent4="accent4" accent5="accent5" accent6="accent6" hlink="hlink" folHlink="folHlink"/>
+  <p:notesStyle>
+    <a:lvl1pPr marL="0" algn="l" defTabSz="914400" rtl="0" eaLnBrk="1" latinLnBrk="0" hangingPunct="1">
+      <a:defRPr sz="1200" kern="1200">
+        <a:solidFill>
+          <a:schemeClr val="tx1"/>
+        </a:solidFill>
+        <a:latin typeface="+mn-lt"/>
+        <a:ea typeface="+mn-ea"/>
+        <a:cs typeface="+mn-cs"/>
+      </a:defRPr>
+    </a:lvl1pPr>
+    <a:lvl2pPr marL="457200" algn="l" defTabSz="914400" rtl="0" eaLnBrk="1" latinLnBrk="0" hangingPunct="1">
+      <a:defRPr sz="1200" kern="1200">
+        <a:solidFill>
+          <a:schemeClr val="tx1"/>
+        </a:solidFill>
+        <a:latin typeface="+mn-lt"/>
+        <a:ea typeface="+mn-ea"/>
+        <a:cs typeface="+mn-cs"/>
+      </a:defRPr>
+    </a:lvl2pPr>
+    <a:lvl3pPr marL="914400" algn="l" defTabSz="914400" rtl="0" eaLnBrk="1" latinLnBrk="0" hangingPunct="1">
+      <a:defRPr sz="1200" kern="1200">
+        <a:solidFill>
+          <a:schemeClr val="tx1"/>
+        </a:solidFill>
+        <a:latin typeface="+mn-lt"/>
+        <a:ea typeface="+mn-ea"/>
+        <a:cs typeface="+mn-cs"/>
+      </a:defRPr>
+    </a:lvl3pPr>
+    <a:lvl4pPr marL="1371600" algn="l" defTabSz="914400" rtl="0" eaLnBrk="1" latinLnBrk="0" hangingPunct="1">
+      <a:defRPr sz="1200" kern="1200">
+        <a:solidFill>
+          <a:schemeClr val="tx1"/>
+        </a:solidFill>
+        <a:latin typeface="+mn-lt"/>
+        <a:ea typeface="+mn-ea"/>
+        <a:cs typeface="+mn-cs"/>
+      </a:defRPr>
+    </a:lvl4pPr>
+    <a:lvl5pPr marL="1828800" algn="l" defTabSz="914400" rtl="0" eaLnBrk="1" latinLnBrk="0" hangingPunct="1">
+      <a:defRPr sz="1200" kern="1200">
+        <a:solidFill>
+          <a:schemeClr val="tx1"/>
+        </a:solidFill>
+        <a:latin typeface="+mn-lt"/>
+        <a:ea typeface="+mn-ea"/>
+        <a:cs typeface="+mn-cs"/>
+      </a:defRPr>
+    </a:lvl5pPr>
+    <a:lvl6pPr marL="2286000" algn="l" defTabSz="914400" rtl="0" eaLnBrk="1" latinLnBrk="0" hangingPunct="1">
+      <a:defRPr sz="1200" kern="1200">
+        <a:solidFill>
+          <a:schemeClr val="tx1"/>
+        </a:solidFill>
+        <a:latin typeface="+mn-lt"/>
+        <a:ea typeface="+mn-ea"/>
+        <a:cs typeface="+mn-cs"/>
+      </a:defRPr>
+    </a:lvl6pPr>
+    <a:lvl7pPr marL="2743200" algn="l" defTabSz="914400" rtl="0" eaLnBrk="1" latinLnBrk="0" hangingPunct="1">
+      <a:defRPr sz="1200" kern="1200">
+        <a:solidFill>
+          <a:schemeClr val="tx1"/>
+        </a:solidFill>
+        <a:latin typeface="+mn-lt"/>
+        <a:ea typeface="+mn-ea"/>
+        <a:cs typeface="+mn-cs"/>
+      </a:defRPr>
+    </a:lvl7pPr>
+    <a:lvl8pPr marL="3200400" algn="l" defTabSz="914400" rtl="0" eaLnBrk="1" latinLnBrk="0" hangingPunct="1">
+      <a:defRPr sz="1200" kern="1200">
+        <a:solidFill>
+          <a:schemeClr val="tx1"/>
+        </a:solidFill>
+        <a:latin typeface="+mn-lt"/>
+        <a:ea typeface="+mn-ea"/>
+        <a:cs typeface="+mn-cs"/>
+      </a:defRPr>
+    </a:lvl8pPr>
+    <a:lvl9pPr marL="3657600" algn="l" defTabSz="914400" rtl="0" eaLnBrk="1" latinLnBrk="0" hangingPunct="1">
+      <a:defRPr sz="1200" kern="1200">
+        <a:solidFill>
+          <a:schemeClr val="tx1"/>
+        </a:solidFill>
+        <a:latin typeface="+mn-lt"/>
+        <a:ea typeface="+mn-ea"/>
+        <a:cs typeface="+mn-cs"/>
+      </a:defRPr>
+    </a:lvl9pPr>
+  </p:notesStyle>
+</p:notesMaster>
+</file>
+
+<file path=ppt/notesSlides/notesSlide1.xml><?xml version="1.0" encoding="utf-8"?>
+<p:notes xmlns:a="http://schemas.openxmlformats.org/drawingml/2006/main" xmlns:r="http://schemas.openxmlformats.org/officeDocument/2006/relationships" xmlns:p="http://schemas.openxmlformats.org/presentationml/2006/main">
+  <p:cSld>
+    <p:spTree>
+      <p:nvGrpSpPr>
+        <p:cNvPr id="1" name=""/>
+        <p:cNvGrpSpPr/>
+        <p:nvPr/>
+      </p:nvGrpSpPr>
+      <p:grpSpPr>
+        <a:xfrm>
+          <a:off x="0" y="0"/>
+          <a:ext cx="0" cy="0"/>
+          <a:chOff x="0" y="0"/>
+          <a:chExt cx="0" cy="0"/>
+        </a:xfrm>
+      </p:grpSpPr>
+      <p:sp>
+        <p:nvSpPr>
+          <p:cNvPr id="2" name="Slide Image Placeholder 1"/>
+          <p:cNvSpPr>
+            <a:spLocks noGrp="1" noRot="1" noChangeAspect="1"/>
+          </p:cNvSpPr>
+          <p:nvPr>
+            <p:ph type="sldImg"/>
+          </p:nvPr>
+        </p:nvSpPr>
+        <p:spPr/>
+      </p:sp>
+      <p:sp>
+        <p:nvSpPr>
+          <p:cNvPr id="3" name="Notes Placeholder 2"/>
+          <p:cNvSpPr>
+            <a:spLocks noGrp="1"/>
+          </p:cNvSpPr>
+          <p:nvPr>
+            <p:ph type="body" idx="1"/>
+          </p:nvPr>
+        </p:nvSpPr>
+        <p:spPr/>
+        <p:txBody>
+          <a:bodyPr/>
+          <a:lstStyle/>
+          <a:p>
+            <a:endParaRPr lang="en-US" dirty="0"/>
+          </a:p>
+        </p:txBody>
+      </p:sp>
+      <p:sp>
+        <p:nvSpPr>
+          <p:cNvPr id="4" name="Slide Number Placeholder 3"/>
+          <p:cNvSpPr>
+            <a:spLocks noGrp="1"/>
+          </p:cNvSpPr>
+          <p:nvPr>
+            <p:ph type="sldNum" sz="quarter" idx="5"/>
+          </p:nvPr>
+        </p:nvSpPr>
+        <p:spPr/>
+        <p:txBody>
+          <a:bodyPr/>
+          <a:lstStyle/>
+          <a:p>
+            <a:fld id="{96A30439-D87D-4C5C-ACC1-25E9A515DBC1}" type="slidenum">
+              <a:rPr lang="en-US" smtClean="0"/>
+              <a:t>8</a:t>
+            </a:fld>
+            <a:endParaRPr lang="en-US"/>
+          </a:p>
+        </p:txBody>
+      </p:sp>
+    </p:spTree>
+    <p:extLst>
+      <p:ext uri="{BB962C8B-B14F-4D97-AF65-F5344CB8AC3E}">
+        <p14:creationId xmlns:p14="http://schemas.microsoft.com/office/powerpoint/2010/main" val="1391845797"/>
+      </p:ext>
+    </p:extLst>
+  </p:cSld>
+  <p:clrMapOvr>
+    <a:masterClrMapping/>
+  </p:clrMapOvr>
+</p:notes>
+</file>
+
 <file path=ppt/slideLayouts/slideLayout1.xml><?xml version="1.0" encoding="utf-8"?>
 <p:sldLayout xmlns:a="http://schemas.openxmlformats.org/drawingml/2006/main" xmlns:r="http://schemas.openxmlformats.org/officeDocument/2006/relationships" xmlns:p="http://schemas.openxmlformats.org/presentationml/2006/main" type="title" preserve="1">
   <p:cSld name="Title Slide">
@@ -261,7 +703,7 @@
           <a:p>
             <a:fld id="{6316C218-4004-4F87-AB00-2790D8F09C66}" type="datetimeFigureOut">
               <a:rPr lang="en-US" smtClean="0"/>
-              <a:t>2/21/2026</a:t>
+              <a:t>2/23/2026</a:t>
             </a:fld>
             <a:endParaRPr lang="en-US"/>
           </a:p>
@@ -459,7 +901,7 @@
           <a:p>
             <a:fld id="{6316C218-4004-4F87-AB00-2790D8F09C66}" type="datetimeFigureOut">
               <a:rPr lang="en-US" smtClean="0"/>
-              <a:t>2/21/2026</a:t>
+              <a:t>2/23/2026</a:t>
             </a:fld>
             <a:endParaRPr lang="en-US"/>
           </a:p>
@@ -667,7 +1109,7 @@
           <a:p>
             <a:fld id="{6316C218-4004-4F87-AB00-2790D8F09C66}" type="datetimeFigureOut">
               <a:rPr lang="en-US" smtClean="0"/>
-              <a:t>2/21/2026</a:t>
+              <a:t>2/23/2026</a:t>
             </a:fld>
             <a:endParaRPr lang="en-US"/>
           </a:p>
@@ -865,7 +1307,7 @@
           <a:p>
             <a:fld id="{6316C218-4004-4F87-AB00-2790D8F09C66}" type="datetimeFigureOut">
               <a:rPr lang="en-US" smtClean="0"/>
-              <a:t>2/21/2026</a:t>
+              <a:t>2/23/2026</a:t>
             </a:fld>
             <a:endParaRPr lang="en-US"/>
           </a:p>
@@ -1140,7 +1582,7 @@
           <a:p>
             <a:fld id="{6316C218-4004-4F87-AB00-2790D8F09C66}" type="datetimeFigureOut">
               <a:rPr lang="en-US" smtClean="0"/>
-              <a:t>2/21/2026</a:t>
+              <a:t>2/23/2026</a:t>
             </a:fld>
             <a:endParaRPr lang="en-US"/>
           </a:p>
@@ -1405,7 +1847,7 @@
           <a:p>
             <a:fld id="{6316C218-4004-4F87-AB00-2790D8F09C66}" type="datetimeFigureOut">
               <a:rPr lang="en-US" smtClean="0"/>
-              <a:t>2/21/2026</a:t>
+              <a:t>2/23/2026</a:t>
             </a:fld>
             <a:endParaRPr lang="en-US"/>
           </a:p>
@@ -1817,7 +2259,7 @@
           <a:p>
             <a:fld id="{6316C218-4004-4F87-AB00-2790D8F09C66}" type="datetimeFigureOut">
               <a:rPr lang="en-US" smtClean="0"/>
-              <a:t>2/21/2026</a:t>
+              <a:t>2/23/2026</a:t>
             </a:fld>
             <a:endParaRPr lang="en-US"/>
           </a:p>
@@ -1958,7 +2400,7 @@
           <a:p>
             <a:fld id="{6316C218-4004-4F87-AB00-2790D8F09C66}" type="datetimeFigureOut">
               <a:rPr lang="en-US" smtClean="0"/>
-              <a:t>2/21/2026</a:t>
+              <a:t>2/23/2026</a:t>
             </a:fld>
             <a:endParaRPr lang="en-US"/>
           </a:p>
@@ -2071,7 +2513,7 @@
           <a:p>
             <a:fld id="{6316C218-4004-4F87-AB00-2790D8F09C66}" type="datetimeFigureOut">
               <a:rPr lang="en-US" smtClean="0"/>
-              <a:t>2/21/2026</a:t>
+              <a:t>2/23/2026</a:t>
             </a:fld>
             <a:endParaRPr lang="en-US"/>
           </a:p>
@@ -2382,7 +2824,7 @@
           <a:p>
             <a:fld id="{6316C218-4004-4F87-AB00-2790D8F09C66}" type="datetimeFigureOut">
               <a:rPr lang="en-US" smtClean="0"/>
-              <a:t>2/21/2026</a:t>
+              <a:t>2/23/2026</a:t>
             </a:fld>
             <a:endParaRPr lang="en-US"/>
           </a:p>
@@ -2670,7 +3112,7 @@
           <a:p>
             <a:fld id="{6316C218-4004-4F87-AB00-2790D8F09C66}" type="datetimeFigureOut">
               <a:rPr lang="en-US" smtClean="0"/>
-              <a:t>2/21/2026</a:t>
+              <a:t>2/23/2026</a:t>
             </a:fld>
             <a:endParaRPr lang="en-US"/>
           </a:p>
@@ -2911,7 +3353,7 @@
           <a:p>
             <a:fld id="{6316C218-4004-4F87-AB00-2790D8F09C66}" type="datetimeFigureOut">
               <a:rPr lang="en-US" smtClean="0"/>
-              <a:t>2/21/2026</a:t>
+              <a:t>2/23/2026</a:t>
             </a:fld>
             <a:endParaRPr lang="en-US"/>
           </a:p>
@@ -3728,10 +4170,2095 @@
           </a:p>
         </p:txBody>
       </p:sp>
+      <p:sp>
+        <p:nvSpPr>
+          <p:cNvPr id="2" name="TextBox 1">
+            <a:extLst>
+              <a:ext uri="{FF2B5EF4-FFF2-40B4-BE49-F238E27FC236}">
+                <a16:creationId xmlns:a16="http://schemas.microsoft.com/office/drawing/2014/main" id="{A331A644-E7D5-4B50-9DCA-39D8EC0584EA}"/>
+              </a:ext>
+            </a:extLst>
+          </p:cNvPr>
+          <p:cNvSpPr txBox="1"/>
+          <p:nvPr/>
+        </p:nvSpPr>
+        <p:spPr>
+          <a:xfrm>
+            <a:off x="960120" y="3822192"/>
+            <a:ext cx="4965192" cy="2031325"/>
+          </a:xfrm>
+          <a:prstGeom prst="rect">
+            <a:avLst/>
+          </a:prstGeom>
+          <a:noFill/>
+        </p:spPr>
+        <p:txBody>
+          <a:bodyPr wrap="square" rtlCol="0">
+            <a:spAutoFit/>
+          </a:bodyPr>
+          <a:lstStyle/>
+          <a:p>
+            <a:r>
+              <a:rPr lang="en-US" b="1" dirty="0"/>
+              <a:t>Requirements</a:t>
+            </a:r>
+          </a:p>
+          <a:p>
+            <a:pPr marL="285750" indent="-285750">
+              <a:buFont typeface="Arial" panose="020B0604020202020204" pitchFamily="34" charset="0"/>
+              <a:buChar char="•"/>
+            </a:pPr>
+            <a:r>
+              <a:rPr lang="en-US" dirty="0"/>
+              <a:t>Python 		&gt;=3.13.0</a:t>
+            </a:r>
+          </a:p>
+          <a:p>
+            <a:pPr marL="285750" indent="-285750">
+              <a:buFont typeface="Arial" panose="020B0604020202020204" pitchFamily="34" charset="0"/>
+              <a:buChar char="•"/>
+            </a:pPr>
+            <a:r>
+              <a:rPr lang="en-US" dirty="0"/>
+              <a:t>PyQt6                   	  	&gt;=6.7.1</a:t>
+            </a:r>
+          </a:p>
+          <a:p>
+            <a:pPr marL="285750" indent="-285750">
+              <a:buFont typeface="Arial" panose="020B0604020202020204" pitchFamily="34" charset="0"/>
+              <a:buChar char="•"/>
+            </a:pPr>
+            <a:r>
+              <a:rPr lang="en-US" dirty="0"/>
+              <a:t>PyQt6-Qt6                   	&gt;=6.7.1</a:t>
+            </a:r>
+          </a:p>
+          <a:p>
+            <a:pPr marL="285750" indent="-285750">
+              <a:buFont typeface="Arial" panose="020B0604020202020204" pitchFamily="34" charset="0"/>
+              <a:buChar char="•"/>
+            </a:pPr>
+            <a:r>
+              <a:rPr lang="en-US" dirty="0"/>
+              <a:t>PyQt6-QtSerialPort 	&gt;=6.7.1</a:t>
+            </a:r>
+          </a:p>
+          <a:p>
+            <a:pPr marL="285750" indent="-285750">
+              <a:buFont typeface="Arial" panose="020B0604020202020204" pitchFamily="34" charset="0"/>
+              <a:buChar char="•"/>
+            </a:pPr>
+            <a:r>
+              <a:rPr lang="en-US" dirty="0"/>
+              <a:t>tabulate                	&gt;=0.9.0</a:t>
+            </a:r>
+          </a:p>
+          <a:p>
+            <a:pPr marL="285750" indent="-285750">
+              <a:buFont typeface="Arial" panose="020B0604020202020204" pitchFamily="34" charset="0"/>
+              <a:buChar char="•"/>
+            </a:pPr>
+            <a:r>
+              <a:rPr lang="en-US" dirty="0" err="1"/>
+              <a:t>pyinstaller</a:t>
+            </a:r>
+            <a:r>
+              <a:rPr lang="en-US" dirty="0"/>
+              <a:t>             	&gt;=5.13.0</a:t>
+            </a:r>
+          </a:p>
+        </p:txBody>
+      </p:sp>
     </p:spTree>
     <p:extLst>
       <p:ext uri="{BB962C8B-B14F-4D97-AF65-F5344CB8AC3E}">
         <p14:creationId xmlns:p14="http://schemas.microsoft.com/office/powerpoint/2010/main" val="2607787864"/>
+      </p:ext>
+    </p:extLst>
+  </p:cSld>
+  <p:clrMapOvr>
+    <a:masterClrMapping/>
+  </p:clrMapOvr>
+</p:sld>
+</file>
+
+<file path=ppt/slides/slide4.xml><?xml version="1.0" encoding="utf-8"?>
+<p:sld xmlns:a="http://schemas.openxmlformats.org/drawingml/2006/main" xmlns:r="http://schemas.openxmlformats.org/officeDocument/2006/relationships" xmlns:p="http://schemas.openxmlformats.org/presentationml/2006/main">
+  <p:cSld>
+    <p:spTree>
+      <p:nvGrpSpPr>
+        <p:cNvPr id="1" name=""/>
+        <p:cNvGrpSpPr/>
+        <p:nvPr/>
+      </p:nvGrpSpPr>
+      <p:grpSpPr>
+        <a:xfrm>
+          <a:off x="0" y="0"/>
+          <a:ext cx="0" cy="0"/>
+          <a:chOff x="0" y="0"/>
+          <a:chExt cx="0" cy="0"/>
+        </a:xfrm>
+      </p:grpSpPr>
+      <p:sp>
+        <p:nvSpPr>
+          <p:cNvPr id="3" name="TextBox 2">
+            <a:extLst>
+              <a:ext uri="{FF2B5EF4-FFF2-40B4-BE49-F238E27FC236}">
+                <a16:creationId xmlns:a16="http://schemas.microsoft.com/office/drawing/2014/main" id="{E49D4217-12D6-ACDE-5CF8-5D831172AA19}"/>
+              </a:ext>
+            </a:extLst>
+          </p:cNvPr>
+          <p:cNvSpPr txBox="1"/>
+          <p:nvPr/>
+        </p:nvSpPr>
+        <p:spPr>
+          <a:xfrm>
+            <a:off x="0" y="424839"/>
+            <a:ext cx="12192000" cy="923330"/>
+          </a:xfrm>
+          <a:prstGeom prst="rect">
+            <a:avLst/>
+          </a:prstGeom>
+          <a:noFill/>
+        </p:spPr>
+        <p:txBody>
+          <a:bodyPr wrap="square">
+            <a:spAutoFit/>
+          </a:bodyPr>
+          <a:lstStyle/>
+          <a:p>
+            <a:r>
+              <a:rPr lang="en-US" b="1" dirty="0"/>
+              <a:t>	Project Repository</a:t>
+            </a:r>
+          </a:p>
+          <a:p>
+            <a:r>
+              <a:rPr lang="en-US" b="1" dirty="0"/>
+              <a:t>		</a:t>
+            </a:r>
+            <a:r>
+              <a:rPr lang="en-US" sz="1400" dirty="0" err="1"/>
+              <a:t>Github</a:t>
+            </a:r>
+            <a:r>
+              <a:rPr lang="en-US" dirty="0"/>
+              <a:t>: </a:t>
+            </a:r>
+            <a:r>
+              <a:rPr lang="en-US" sz="1400" dirty="0">
+                <a:hlinkClick r:id="rId2"/>
+              </a:rPr>
+              <a:t>https://github.com/OliverFeronel090597/E-Viotrack.git</a:t>
+            </a:r>
+            <a:endParaRPr lang="en-US" sz="1400" dirty="0"/>
+          </a:p>
+          <a:p>
+            <a:r>
+              <a:rPr lang="en-US" dirty="0"/>
+              <a:t>	</a:t>
+            </a:r>
+          </a:p>
+        </p:txBody>
+      </p:sp>
+      <p:sp>
+        <p:nvSpPr>
+          <p:cNvPr id="4" name="TextBox 3">
+            <a:extLst>
+              <a:ext uri="{FF2B5EF4-FFF2-40B4-BE49-F238E27FC236}">
+                <a16:creationId xmlns:a16="http://schemas.microsoft.com/office/drawing/2014/main" id="{7586F94F-D226-52EC-A0F5-E8774C31855B}"/>
+              </a:ext>
+            </a:extLst>
+          </p:cNvPr>
+          <p:cNvSpPr txBox="1"/>
+          <p:nvPr/>
+        </p:nvSpPr>
+        <p:spPr>
+          <a:xfrm>
+            <a:off x="850392" y="989511"/>
+            <a:ext cx="6071616" cy="5878532"/>
+          </a:xfrm>
+          <a:prstGeom prst="rect">
+            <a:avLst/>
+          </a:prstGeom>
+          <a:noFill/>
+        </p:spPr>
+        <p:txBody>
+          <a:bodyPr wrap="square" rtlCol="0">
+            <a:spAutoFit/>
+          </a:bodyPr>
+          <a:lstStyle/>
+          <a:p>
+            <a:endParaRPr lang="en-US" sz="800" dirty="0">
+              <a:latin typeface="Monospac821 BT" panose="020B0609020202020204" pitchFamily="49" charset="0"/>
+            </a:endParaRPr>
+          </a:p>
+          <a:p>
+            <a:r>
+              <a:rPr lang="en-US" sz="800" dirty="0">
+                <a:latin typeface="Monospac821 BT" panose="020B0609020202020204" pitchFamily="49" charset="0"/>
+              </a:rPr>
+              <a:t>E-</a:t>
+            </a:r>
+            <a:r>
+              <a:rPr lang="en-US" sz="800" dirty="0" err="1">
+                <a:latin typeface="Monospac821 BT" panose="020B0609020202020204" pitchFamily="49" charset="0"/>
+              </a:rPr>
+              <a:t>Viotrack</a:t>
+            </a:r>
+            <a:r>
+              <a:rPr lang="en-US" sz="800" dirty="0">
+                <a:latin typeface="Monospac821 BT" panose="020B0609020202020204" pitchFamily="49" charset="0"/>
+              </a:rPr>
+              <a:t>/</a:t>
+            </a:r>
+          </a:p>
+          <a:p>
+            <a:r>
+              <a:rPr lang="en-US" sz="800" dirty="0">
+                <a:latin typeface="Monospac821 BT" panose="020B0609020202020204" pitchFamily="49" charset="0"/>
+              </a:rPr>
+              <a:t>├── E_Viotrack.py              	# Main application entry point</a:t>
+            </a:r>
+          </a:p>
+          <a:p>
+            <a:r>
+              <a:rPr lang="en-US" sz="800" dirty="0">
+                <a:latin typeface="Monospac821 BT" panose="020B0609020202020204" pitchFamily="49" charset="0"/>
+              </a:rPr>
+              <a:t>├── requirements.txt           	# Python dependencies</a:t>
+            </a:r>
+          </a:p>
+          <a:p>
+            <a:r>
+              <a:rPr lang="en-US" sz="800" dirty="0">
+                <a:latin typeface="Monospac821 BT" panose="020B0609020202020204" pitchFamily="49" charset="0"/>
+              </a:rPr>
+              <a:t>├── README.md                  	# This file</a:t>
+            </a:r>
+          </a:p>
+          <a:p>
+            <a:r>
+              <a:rPr lang="en-US" sz="800" dirty="0">
+                <a:latin typeface="Monospac821 BT" panose="020B0609020202020204" pitchFamily="49" charset="0"/>
+              </a:rPr>
+              <a:t>├── </a:t>
+            </a:r>
+            <a:r>
+              <a:rPr lang="en-US" sz="800" dirty="0" err="1">
+                <a:latin typeface="Monospac821 BT" panose="020B0609020202020204" pitchFamily="49" charset="0"/>
+              </a:rPr>
+              <a:t>db</a:t>
+            </a:r>
+            <a:r>
+              <a:rPr lang="en-US" sz="800" dirty="0">
+                <a:latin typeface="Monospac821 BT" panose="020B0609020202020204" pitchFamily="49" charset="0"/>
+              </a:rPr>
+              <a:t>/                        	# SQLite database files</a:t>
+            </a:r>
+          </a:p>
+          <a:p>
+            <a:r>
+              <a:rPr lang="en-US" sz="800" dirty="0">
+                <a:latin typeface="Monospac821 BT" panose="020B0609020202020204" pitchFamily="49" charset="0"/>
+              </a:rPr>
+              <a:t>├── libs/                      	# Core application modules</a:t>
+            </a:r>
+          </a:p>
+          <a:p>
+            <a:r>
+              <a:rPr lang="en-US" sz="800" dirty="0">
+                <a:latin typeface="Monospac821 BT" panose="020B0609020202020204" pitchFamily="49" charset="0"/>
+              </a:rPr>
+              <a:t>│   ├── Homepage.py            	# Home page interface</a:t>
+            </a:r>
+          </a:p>
+          <a:p>
+            <a:r>
+              <a:rPr lang="en-US" sz="800" dirty="0">
+                <a:latin typeface="Monospac821 BT" panose="020B0609020202020204" pitchFamily="49" charset="0"/>
+              </a:rPr>
+              <a:t>│   ├── LogPage.py             	# Activity logs display</a:t>
+            </a:r>
+          </a:p>
+          <a:p>
+            <a:r>
+              <a:rPr lang="en-US" sz="800" dirty="0">
+                <a:latin typeface="Monospac821 BT" panose="020B0609020202020204" pitchFamily="49" charset="0"/>
+              </a:rPr>
+              <a:t>│   ├── Adminpage.py           	# Admin panel</a:t>
+            </a:r>
+          </a:p>
+          <a:p>
+            <a:r>
+              <a:rPr lang="en-US" sz="800" dirty="0">
+                <a:latin typeface="Monospac821 BT" panose="020B0609020202020204" pitchFamily="49" charset="0"/>
+              </a:rPr>
+              <a:t>│   ├── AdvancePage.py         	# Advanced settings</a:t>
+            </a:r>
+          </a:p>
+          <a:p>
+            <a:r>
+              <a:rPr lang="en-US" sz="800" dirty="0">
+                <a:latin typeface="Monospac821 BT" panose="020B0609020202020204" pitchFamily="49" charset="0"/>
+              </a:rPr>
+              <a:t>│   ├── ReadSerial.py          	# RFID serial communication</a:t>
+            </a:r>
+          </a:p>
+          <a:p>
+            <a:r>
+              <a:rPr lang="en-US" sz="800" dirty="0">
+                <a:latin typeface="Monospac821 BT" panose="020B0609020202020204" pitchFamily="49" charset="0"/>
+              </a:rPr>
+              <a:t>│   ├── DatabaseConnector.py  	# SQLite database operations</a:t>
+            </a:r>
+          </a:p>
+          <a:p>
+            <a:r>
+              <a:rPr lang="en-US" sz="800" dirty="0">
+                <a:latin typeface="Monospac821 BT" panose="020B0609020202020204" pitchFamily="49" charset="0"/>
+              </a:rPr>
+              <a:t>│   ├── NotificationManager.py 	# User notifications</a:t>
+            </a:r>
+          </a:p>
+          <a:p>
+            <a:r>
+              <a:rPr lang="en-US" sz="800" dirty="0">
+                <a:latin typeface="Monospac821 BT" panose="020B0609020202020204" pitchFamily="49" charset="0"/>
+              </a:rPr>
+              <a:t>│   ├── CustomTable.py         	# Custom table widget</a:t>
+            </a:r>
+          </a:p>
+          <a:p>
+            <a:r>
+              <a:rPr lang="en-US" sz="800" dirty="0">
+                <a:latin typeface="Monospac821 BT" panose="020B0609020202020204" pitchFamily="49" charset="0"/>
+              </a:rPr>
+              <a:t>│   ├── Animatedstack.py       	# Animated page transitions</a:t>
+            </a:r>
+          </a:p>
+          <a:p>
+            <a:r>
+              <a:rPr lang="en-US" sz="800" dirty="0">
+                <a:latin typeface="Monospac821 BT" panose="020B0609020202020204" pitchFamily="49" charset="0"/>
+              </a:rPr>
+              <a:t>│   ├── GlobalVariable.py      	# Global configuration</a:t>
+            </a:r>
+          </a:p>
+          <a:p>
+            <a:r>
+              <a:rPr lang="en-US" sz="800" dirty="0">
+                <a:latin typeface="Monospac821 BT" panose="020B0609020202020204" pitchFamily="49" charset="0"/>
+              </a:rPr>
+              <a:t>│   ├── Settings.py            	# RFID manager settings</a:t>
+            </a:r>
+          </a:p>
+          <a:p>
+            <a:r>
+              <a:rPr lang="en-US" sz="800" dirty="0">
+                <a:latin typeface="Monospac821 BT" panose="020B0609020202020204" pitchFamily="49" charset="0"/>
+              </a:rPr>
+              <a:t>│   ├── Hasher.py              	# Password hashing utilities</a:t>
+            </a:r>
+          </a:p>
+          <a:p>
+            <a:r>
+              <a:rPr lang="en-US" sz="800" dirty="0">
+                <a:latin typeface="Monospac821 BT" panose="020B0609020202020204" pitchFamily="49" charset="0"/>
+              </a:rPr>
+              <a:t>│   ├── DriverTableWidget.py   	# Driver table widget</a:t>
+            </a:r>
+          </a:p>
+          <a:p>
+            <a:r>
+              <a:rPr lang="en-US" sz="800" dirty="0">
+                <a:latin typeface="Monospac821 BT" panose="020B0609020202020204" pitchFamily="49" charset="0"/>
+              </a:rPr>
+              <a:t>│   ├── EditDriverDialog.py    	# Edit driver dialog</a:t>
+            </a:r>
+          </a:p>
+          <a:p>
+            <a:r>
+              <a:rPr lang="en-US" sz="800" dirty="0">
+                <a:latin typeface="Monospac821 BT" panose="020B0609020202020204" pitchFamily="49" charset="0"/>
+              </a:rPr>
+              <a:t>│   ├── EditUserDialog.py      	# Edit user dialog</a:t>
+            </a:r>
+          </a:p>
+          <a:p>
+            <a:r>
+              <a:rPr lang="en-US" sz="800" dirty="0">
+                <a:latin typeface="Monospac821 BT" panose="020B0609020202020204" pitchFamily="49" charset="0"/>
+              </a:rPr>
+              <a:t>│   ├── EditViolationDialog.py 	# Edit violation dialog</a:t>
+            </a:r>
+          </a:p>
+          <a:p>
+            <a:r>
+              <a:rPr lang="en-US" sz="800" dirty="0">
+                <a:latin typeface="Monospac821 BT" panose="020B0609020202020204" pitchFamily="49" charset="0"/>
+              </a:rPr>
+              <a:t>│   ├── EditViolationTypeDialog.py 	# Edit violation type dialog</a:t>
+            </a:r>
+          </a:p>
+          <a:p>
+            <a:r>
+              <a:rPr lang="en-US" sz="800" dirty="0">
+                <a:latin typeface="Monospac821 BT" panose="020B0609020202020204" pitchFamily="49" charset="0"/>
+              </a:rPr>
+              <a:t>│   ├── Globalenentfilter.py   	# Global event filter</a:t>
+            </a:r>
+          </a:p>
+          <a:p>
+            <a:r>
+              <a:rPr lang="en-US" sz="800" dirty="0">
+                <a:latin typeface="Monospac821 BT" panose="020B0609020202020204" pitchFamily="49" charset="0"/>
+              </a:rPr>
+              <a:t>│   ├── RFIDWorker.py          	# RFID worker thread</a:t>
+            </a:r>
+          </a:p>
+          <a:p>
+            <a:r>
+              <a:rPr lang="en-US" sz="800" dirty="0">
+                <a:latin typeface="Monospac821 BT" panose="020B0609020202020204" pitchFamily="49" charset="0"/>
+              </a:rPr>
+              <a:t>│   ├── SerialReaderThread.py  	# Serial reader thread</a:t>
+            </a:r>
+          </a:p>
+          <a:p>
+            <a:r>
+              <a:rPr lang="en-US" sz="800" dirty="0">
+                <a:latin typeface="Monospac821 BT" panose="020B0609020202020204" pitchFamily="49" charset="0"/>
+              </a:rPr>
+              <a:t>│   ├── UserDriverEditView.py  	# User/driver edit view</a:t>
+            </a:r>
+          </a:p>
+          <a:p>
+            <a:r>
+              <a:rPr lang="en-US" sz="800" dirty="0">
+                <a:latin typeface="Monospac821 BT" panose="020B0609020202020204" pitchFamily="49" charset="0"/>
+              </a:rPr>
+              <a:t>│   ├── UserTableWidget.py     	# User table widget</a:t>
+            </a:r>
+          </a:p>
+          <a:p>
+            <a:r>
+              <a:rPr lang="en-US" sz="800" dirty="0">
+                <a:latin typeface="Monospac821 BT" panose="020B0609020202020204" pitchFamily="49" charset="0"/>
+              </a:rPr>
+              <a:t>│   ├── ViolationTableWidget.py 	# Violation table widget</a:t>
+            </a:r>
+          </a:p>
+          <a:p>
+            <a:r>
+              <a:rPr lang="en-US" sz="800" dirty="0">
+                <a:latin typeface="Monospac821 BT" panose="020B0609020202020204" pitchFamily="49" charset="0"/>
+              </a:rPr>
+              <a:t>│   ├── ViolationTree.py       	# Violation tree widget</a:t>
+            </a:r>
+          </a:p>
+          <a:p>
+            <a:r>
+              <a:rPr lang="en-US" sz="800" dirty="0">
+                <a:latin typeface="Monospac821 BT" panose="020B0609020202020204" pitchFamily="49" charset="0"/>
+              </a:rPr>
+              <a:t>│   ├── ViolationTypeTableWidget.py 	# Violation type table widget</a:t>
+            </a:r>
+          </a:p>
+          <a:p>
+            <a:r>
+              <a:rPr lang="en-US" sz="800" dirty="0">
+                <a:latin typeface="Monospac821 BT" panose="020B0609020202020204" pitchFamily="49" charset="0"/>
+              </a:rPr>
+              <a:t>│   ├── CompleterLineEdit.py   	# Line edit with auto-complete</a:t>
+            </a:r>
+          </a:p>
+          <a:p>
+            <a:r>
+              <a:rPr lang="en-US" sz="800" dirty="0">
+                <a:latin typeface="Monospac821 BT" panose="020B0609020202020204" pitchFamily="49" charset="0"/>
+              </a:rPr>
+              <a:t>│   ├── AutoCapital.py        	# Auto-capitalization utility</a:t>
+            </a:r>
+          </a:p>
+          <a:p>
+            <a:r>
+              <a:rPr lang="en-US" sz="800" dirty="0">
+                <a:latin typeface="Monospac821 BT" panose="020B0609020202020204" pitchFamily="49" charset="0"/>
+              </a:rPr>
+              <a:t>│   ├── AutoStyle.py           	# Auto-style helper</a:t>
+            </a:r>
+          </a:p>
+          <a:p>
+            <a:r>
+              <a:rPr lang="en-US" sz="800" dirty="0">
+                <a:latin typeface="Monospac821 BT" panose="020B0609020202020204" pitchFamily="49" charset="0"/>
+              </a:rPr>
+              <a:t>│   ├── AutoSuggestTextEdit.py 	# Auto-suggest text edit</a:t>
+            </a:r>
+          </a:p>
+          <a:p>
+            <a:r>
+              <a:rPr lang="en-US" sz="800" dirty="0">
+                <a:latin typeface="Monospac821 BT" panose="020B0609020202020204" pitchFamily="49" charset="0"/>
+              </a:rPr>
+              <a:t>│   ├── Imagelabel.py          	# Image label widget</a:t>
+            </a:r>
+          </a:p>
+          <a:p>
+            <a:r>
+              <a:rPr lang="en-US" sz="800" dirty="0">
+                <a:latin typeface="Monospac821 BT" panose="020B0609020202020204" pitchFamily="49" charset="0"/>
+              </a:rPr>
+              <a:t>│   ├── Imagewididget.py       	# Image widget</a:t>
+            </a:r>
+          </a:p>
+          <a:p>
+            <a:r>
+              <a:rPr lang="en-US" sz="800" dirty="0">
+                <a:latin typeface="Monospac821 BT" panose="020B0609020202020204" pitchFamily="49" charset="0"/>
+              </a:rPr>
+              <a:t>│   ├── LineClickTextEdit.py   	# Clickable text edit</a:t>
+            </a:r>
+          </a:p>
+          <a:p>
+            <a:r>
+              <a:rPr lang="en-US" sz="800" dirty="0">
+                <a:latin typeface="Monospac821 BT" panose="020B0609020202020204" pitchFamily="49" charset="0"/>
+              </a:rPr>
+              <a:t>│   ├── LogsViewPage.py        	# Logs view page</a:t>
+            </a:r>
+          </a:p>
+          <a:p>
+            <a:r>
+              <a:rPr lang="en-US" sz="800" dirty="0">
+                <a:latin typeface="Monospac821 BT" panose="020B0609020202020204" pitchFamily="49" charset="0"/>
+              </a:rPr>
+              <a:t>│   ├── SlideNotification.py   	# Slide notifications</a:t>
+            </a:r>
+          </a:p>
+          <a:p>
+            <a:r>
+              <a:rPr lang="en-US" sz="800" dirty="0">
+                <a:latin typeface="Monospac821 BT" panose="020B0609020202020204" pitchFamily="49" charset="0"/>
+              </a:rPr>
+              <a:t>│   ├── stylesheetModefier.py  	# Stylesheet modifier</a:t>
+            </a:r>
+          </a:p>
+          <a:p>
+            <a:r>
+              <a:rPr lang="en-US" sz="800" dirty="0">
+                <a:latin typeface="Monospac821 BT" panose="020B0609020202020204" pitchFamily="49" charset="0"/>
+              </a:rPr>
+              <a:t>│   ├── TablePrint.py          	# Table printing utility</a:t>
+            </a:r>
+          </a:p>
+          <a:p>
+            <a:r>
+              <a:rPr lang="en-US" sz="800" dirty="0">
+                <a:latin typeface="Monospac821 BT" panose="020B0609020202020204" pitchFamily="49" charset="0"/>
+              </a:rPr>
+              <a:t>│   ├── TagListWidget.py       	# Tag list widget</a:t>
+            </a:r>
+          </a:p>
+          <a:p>
+            <a:r>
+              <a:rPr lang="en-US" sz="800" dirty="0">
+                <a:latin typeface="Monospac821 BT" panose="020B0609020202020204" pitchFamily="49" charset="0"/>
+              </a:rPr>
+              <a:t>│   ├── UniqueID.py            	# Unique ID generator</a:t>
+            </a:r>
+          </a:p>
+          <a:p>
+            <a:r>
+              <a:rPr lang="en-US" sz="800" dirty="0">
+                <a:latin typeface="Monospac821 BT" panose="020B0609020202020204" pitchFamily="49" charset="0"/>
+              </a:rPr>
+              <a:t>│   ├── resources.py           	# Application resources (icons/images)</a:t>
+            </a:r>
+          </a:p>
+          <a:p>
+            <a:endParaRPr lang="en-US" sz="800" dirty="0">
+              <a:latin typeface="Monospac821 BT" panose="020B0609020202020204" pitchFamily="49" charset="0"/>
+            </a:endParaRPr>
+          </a:p>
+        </p:txBody>
+      </p:sp>
+    </p:spTree>
+    <p:extLst>
+      <p:ext uri="{BB962C8B-B14F-4D97-AF65-F5344CB8AC3E}">
+        <p14:creationId xmlns:p14="http://schemas.microsoft.com/office/powerpoint/2010/main" val="3586346602"/>
+      </p:ext>
+    </p:extLst>
+  </p:cSld>
+  <p:clrMapOvr>
+    <a:masterClrMapping/>
+  </p:clrMapOvr>
+</p:sld>
+</file>
+
+<file path=ppt/slides/slide5.xml><?xml version="1.0" encoding="utf-8"?>
+<p:sld xmlns:a="http://schemas.openxmlformats.org/drawingml/2006/main" xmlns:r="http://schemas.openxmlformats.org/officeDocument/2006/relationships" xmlns:p="http://schemas.openxmlformats.org/presentationml/2006/main">
+  <p:cSld>
+    <p:spTree>
+      <p:nvGrpSpPr>
+        <p:cNvPr id="1" name="">
+          <a:extLst>
+            <a:ext uri="{FF2B5EF4-FFF2-40B4-BE49-F238E27FC236}">
+              <a16:creationId xmlns:a16="http://schemas.microsoft.com/office/drawing/2014/main" id="{7C91C656-2BFD-3E99-4294-EDD9E3220074}"/>
+            </a:ext>
+          </a:extLst>
+        </p:cNvPr>
+        <p:cNvGrpSpPr/>
+        <p:nvPr/>
+      </p:nvGrpSpPr>
+      <p:grpSpPr>
+        <a:xfrm>
+          <a:off x="0" y="0"/>
+          <a:ext cx="0" cy="0"/>
+          <a:chOff x="0" y="0"/>
+          <a:chExt cx="0" cy="0"/>
+        </a:xfrm>
+      </p:grpSpPr>
+      <p:sp>
+        <p:nvSpPr>
+          <p:cNvPr id="4" name="TextBox 3">
+            <a:extLst>
+              <a:ext uri="{FF2B5EF4-FFF2-40B4-BE49-F238E27FC236}">
+                <a16:creationId xmlns:a16="http://schemas.microsoft.com/office/drawing/2014/main" id="{45079E0D-5CA0-7529-7645-7C34AAA3E137}"/>
+              </a:ext>
+            </a:extLst>
+          </p:cNvPr>
+          <p:cNvSpPr txBox="1"/>
+          <p:nvPr/>
+        </p:nvSpPr>
+        <p:spPr>
+          <a:xfrm>
+            <a:off x="960120" y="987552"/>
+            <a:ext cx="10506456" cy="2000548"/>
+          </a:xfrm>
+          <a:prstGeom prst="rect">
+            <a:avLst/>
+          </a:prstGeom>
+          <a:noFill/>
+        </p:spPr>
+        <p:txBody>
+          <a:bodyPr wrap="square" rtlCol="0">
+            <a:spAutoFit/>
+          </a:bodyPr>
+          <a:lstStyle/>
+          <a:p>
+            <a:r>
+              <a:rPr lang="en-US" b="1" dirty="0"/>
+              <a:t>Database</a:t>
+            </a:r>
+          </a:p>
+          <a:p>
+            <a:r>
+              <a:rPr lang="en-US" sz="1400" dirty="0"/>
+              <a:t>The application uses SQLite to store:</a:t>
+            </a:r>
+          </a:p>
+          <a:p>
+            <a:r>
+              <a:rPr lang="en-US" sz="1400" dirty="0"/>
+              <a:t>Driver/user profiles</a:t>
+            </a:r>
+          </a:p>
+          <a:p>
+            <a:r>
+              <a:rPr lang="en-US" sz="1400" dirty="0"/>
+              <a:t>RFID tag mappings</a:t>
+            </a:r>
+          </a:p>
+          <a:p>
+            <a:r>
+              <a:rPr lang="en-US" sz="1400" dirty="0"/>
+              <a:t>Violation records and types</a:t>
+            </a:r>
+          </a:p>
+          <a:p>
+            <a:r>
+              <a:rPr lang="en-US" sz="1400" dirty="0"/>
+              <a:t>User activity logs</a:t>
+            </a:r>
+          </a:p>
+          <a:p>
+            <a:br>
+              <a:rPr lang="en-US" dirty="0"/>
+            </a:br>
+            <a:endParaRPr lang="en-US" dirty="0"/>
+          </a:p>
+        </p:txBody>
+      </p:sp>
+      <p:sp>
+        <p:nvSpPr>
+          <p:cNvPr id="2" name="TextBox 1">
+            <a:extLst>
+              <a:ext uri="{FF2B5EF4-FFF2-40B4-BE49-F238E27FC236}">
+                <a16:creationId xmlns:a16="http://schemas.microsoft.com/office/drawing/2014/main" id="{C72831B5-5C63-36B3-FD5D-286271A65B2D}"/>
+              </a:ext>
+            </a:extLst>
+          </p:cNvPr>
+          <p:cNvSpPr txBox="1"/>
+          <p:nvPr/>
+        </p:nvSpPr>
+        <p:spPr>
+          <a:xfrm>
+            <a:off x="960120" y="2596896"/>
+            <a:ext cx="6464808" cy="1292662"/>
+          </a:xfrm>
+          <a:prstGeom prst="rect">
+            <a:avLst/>
+          </a:prstGeom>
+          <a:noFill/>
+        </p:spPr>
+        <p:txBody>
+          <a:bodyPr wrap="square" rtlCol="0">
+            <a:spAutoFit/>
+          </a:bodyPr>
+          <a:lstStyle/>
+          <a:p>
+            <a:r>
+              <a:rPr lang="en-US" b="1" dirty="0"/>
+              <a:t>Hardware</a:t>
+            </a:r>
+          </a:p>
+          <a:p>
+            <a:r>
+              <a:rPr lang="en-US" sz="1400" dirty="0"/>
+              <a:t>The application is designed to work with long-range RFID readers connected via:</a:t>
+            </a:r>
+          </a:p>
+          <a:p>
+            <a:r>
+              <a:rPr lang="en-US" sz="1400" b="1" dirty="0"/>
+              <a:t>Serial Connection</a:t>
+            </a:r>
+            <a:r>
+              <a:rPr lang="en-US" sz="1400" dirty="0"/>
+              <a:t>: RS232 to USB adapter</a:t>
+            </a:r>
+          </a:p>
+          <a:p>
+            <a:r>
+              <a:rPr lang="en-US" sz="1400" b="1" dirty="0"/>
+              <a:t>Standard USB</a:t>
+            </a:r>
+            <a:r>
+              <a:rPr lang="en-US" sz="1400" dirty="0"/>
+              <a:t>: Direct USB connection to RFID reader</a:t>
+            </a:r>
+          </a:p>
+          <a:p>
+            <a:endParaRPr lang="en-US" dirty="0"/>
+          </a:p>
+        </p:txBody>
+      </p:sp>
+      <p:sp>
+        <p:nvSpPr>
+          <p:cNvPr id="3" name="TextBox 2">
+            <a:extLst>
+              <a:ext uri="{FF2B5EF4-FFF2-40B4-BE49-F238E27FC236}">
+                <a16:creationId xmlns:a16="http://schemas.microsoft.com/office/drawing/2014/main" id="{E8D47162-1102-9A38-C8A2-01C71A0BF55C}"/>
+              </a:ext>
+            </a:extLst>
+          </p:cNvPr>
+          <p:cNvSpPr txBox="1"/>
+          <p:nvPr/>
+        </p:nvSpPr>
+        <p:spPr>
+          <a:xfrm>
+            <a:off x="960120" y="3869901"/>
+            <a:ext cx="8156448" cy="861774"/>
+          </a:xfrm>
+          <a:prstGeom prst="rect">
+            <a:avLst/>
+          </a:prstGeom>
+          <a:noFill/>
+        </p:spPr>
+        <p:txBody>
+          <a:bodyPr wrap="square" rtlCol="0">
+            <a:spAutoFit/>
+          </a:bodyPr>
+          <a:lstStyle/>
+          <a:p>
+            <a:r>
+              <a:rPr lang="en-US" b="1" dirty="0"/>
+              <a:t>License</a:t>
+            </a:r>
+            <a:endParaRPr lang="en-US" dirty="0"/>
+          </a:p>
+          <a:p>
+            <a:r>
+              <a:rPr lang="en-US" sz="1400" dirty="0"/>
+              <a:t>Qt6 GUI Framework (LGPLv3): </a:t>
+            </a:r>
+            <a:r>
+              <a:rPr lang="en-US" sz="1400" dirty="0">
+                <a:hlinkClick r:id="rId2"/>
+              </a:rPr>
+              <a:t>https://www.qt.io/licensing</a:t>
+            </a:r>
+            <a:r>
+              <a:rPr lang="en-US" sz="1400" dirty="0"/>
+              <a:t> Qt6 Licensing</a:t>
+            </a:r>
+          </a:p>
+          <a:p>
+            <a:endParaRPr lang="en-US" dirty="0"/>
+          </a:p>
+        </p:txBody>
+      </p:sp>
+    </p:spTree>
+    <p:extLst>
+      <p:ext uri="{BB962C8B-B14F-4D97-AF65-F5344CB8AC3E}">
+        <p14:creationId xmlns:p14="http://schemas.microsoft.com/office/powerpoint/2010/main" val="2561122436"/>
+      </p:ext>
+    </p:extLst>
+  </p:cSld>
+  <p:clrMapOvr>
+    <a:masterClrMapping/>
+  </p:clrMapOvr>
+</p:sld>
+</file>
+
+<file path=ppt/slides/slide6.xml><?xml version="1.0" encoding="utf-8"?>
+<p:sld xmlns:a="http://schemas.openxmlformats.org/drawingml/2006/main" xmlns:r="http://schemas.openxmlformats.org/officeDocument/2006/relationships" xmlns:p="http://schemas.openxmlformats.org/presentationml/2006/main">
+  <p:cSld>
+    <p:spTree>
+      <p:nvGrpSpPr>
+        <p:cNvPr id="1" name="">
+          <a:extLst>
+            <a:ext uri="{FF2B5EF4-FFF2-40B4-BE49-F238E27FC236}">
+              <a16:creationId xmlns:a16="http://schemas.microsoft.com/office/drawing/2014/main" id="{CA8C588B-5865-1293-0C48-777E534D8FBD}"/>
+            </a:ext>
+          </a:extLst>
+        </p:cNvPr>
+        <p:cNvGrpSpPr/>
+        <p:nvPr/>
+      </p:nvGrpSpPr>
+      <p:grpSpPr>
+        <a:xfrm>
+          <a:off x="0" y="0"/>
+          <a:ext cx="0" cy="0"/>
+          <a:chOff x="0" y="0"/>
+          <a:chExt cx="0" cy="0"/>
+        </a:xfrm>
+      </p:grpSpPr>
+      <p:sp>
+        <p:nvSpPr>
+          <p:cNvPr id="4" name="TextBox 3">
+            <a:extLst>
+              <a:ext uri="{FF2B5EF4-FFF2-40B4-BE49-F238E27FC236}">
+                <a16:creationId xmlns:a16="http://schemas.microsoft.com/office/drawing/2014/main" id="{8051054B-85EF-9AC7-18D7-6A7A7CE33256}"/>
+              </a:ext>
+            </a:extLst>
+          </p:cNvPr>
+          <p:cNvSpPr txBox="1"/>
+          <p:nvPr/>
+        </p:nvSpPr>
+        <p:spPr>
+          <a:xfrm>
+            <a:off x="960120" y="987552"/>
+            <a:ext cx="10506456" cy="1785104"/>
+          </a:xfrm>
+          <a:prstGeom prst="rect">
+            <a:avLst/>
+          </a:prstGeom>
+          <a:noFill/>
+        </p:spPr>
+        <p:txBody>
+          <a:bodyPr wrap="square" rtlCol="0">
+            <a:spAutoFit/>
+          </a:bodyPr>
+          <a:lstStyle/>
+          <a:p>
+            <a:r>
+              <a:rPr lang="en-US" b="1" dirty="0"/>
+              <a:t>Home</a:t>
+            </a:r>
+          </a:p>
+          <a:p>
+            <a:pPr lvl="1"/>
+            <a:r>
+              <a:rPr lang="en-US" sz="1400" dirty="0"/>
+              <a:t>Table 1:</a:t>
+            </a:r>
+          </a:p>
+          <a:p>
+            <a:pPr lvl="1"/>
+            <a:r>
+              <a:rPr lang="en-US" sz="1400" dirty="0"/>
+              <a:t>	Display scan RFID driver if has active violation, Auto remove once paid in the system.</a:t>
+            </a:r>
+          </a:p>
+          <a:p>
+            <a:pPr lvl="1"/>
+            <a:r>
+              <a:rPr lang="en-US" sz="1400" dirty="0"/>
+              <a:t>Table 2:</a:t>
+            </a:r>
+          </a:p>
+          <a:p>
+            <a:pPr lvl="1"/>
+            <a:r>
+              <a:rPr lang="en-US" sz="1400" dirty="0"/>
+              <a:t>	Show driver all violation details when click on name in table 1 </a:t>
+            </a:r>
+          </a:p>
+          <a:p>
+            <a:br>
+              <a:rPr lang="en-US" dirty="0"/>
+            </a:br>
+            <a:endParaRPr lang="en-US" dirty="0"/>
+          </a:p>
+        </p:txBody>
+      </p:sp>
+      <p:sp>
+        <p:nvSpPr>
+          <p:cNvPr id="2" name="TextBox 1">
+            <a:extLst>
+              <a:ext uri="{FF2B5EF4-FFF2-40B4-BE49-F238E27FC236}">
+                <a16:creationId xmlns:a16="http://schemas.microsoft.com/office/drawing/2014/main" id="{C6672519-ECAF-2142-6A45-2099CEE0D71F}"/>
+              </a:ext>
+            </a:extLst>
+          </p:cNvPr>
+          <p:cNvSpPr txBox="1"/>
+          <p:nvPr/>
+        </p:nvSpPr>
+        <p:spPr>
+          <a:xfrm>
+            <a:off x="960120" y="2567226"/>
+            <a:ext cx="10506456" cy="3231654"/>
+          </a:xfrm>
+          <a:prstGeom prst="rect">
+            <a:avLst/>
+          </a:prstGeom>
+          <a:noFill/>
+        </p:spPr>
+        <p:txBody>
+          <a:bodyPr wrap="square" rtlCol="0">
+            <a:spAutoFit/>
+          </a:bodyPr>
+          <a:lstStyle/>
+          <a:p>
+            <a:r>
+              <a:rPr lang="en-US" b="1" dirty="0"/>
+              <a:t>Admin</a:t>
+            </a:r>
+          </a:p>
+          <a:p>
+            <a:r>
+              <a:rPr lang="en-US" sz="1400" b="1" dirty="0"/>
+              <a:t>             </a:t>
+            </a:r>
+            <a:r>
+              <a:rPr lang="en-US" sz="1400" dirty="0"/>
+              <a:t>Login:</a:t>
+            </a:r>
+          </a:p>
+          <a:p>
+            <a:pPr lvl="1"/>
+            <a:r>
+              <a:rPr lang="en-US" sz="1400" dirty="0"/>
+              <a:t>	New open/installed app login with (</a:t>
+            </a:r>
+            <a:r>
+              <a:rPr lang="en-US" sz="1400" dirty="0" err="1">
+                <a:solidFill>
+                  <a:srgbClr val="FF0000"/>
+                </a:solidFill>
+              </a:rPr>
+              <a:t>Usename</a:t>
+            </a:r>
+            <a:r>
+              <a:rPr lang="en-US" sz="1400" dirty="0">
+                <a:solidFill>
+                  <a:srgbClr val="FF0000"/>
+                </a:solidFill>
+              </a:rPr>
+              <a:t>: admin : Password: admin</a:t>
+            </a:r>
+            <a:r>
+              <a:rPr lang="en-US" sz="1400" dirty="0"/>
+              <a:t>)</a:t>
+            </a:r>
+          </a:p>
+          <a:p>
+            <a:pPr lvl="1"/>
+            <a:r>
+              <a:rPr lang="en-US" sz="1400" dirty="0"/>
+              <a:t>System User:</a:t>
+            </a:r>
+          </a:p>
+          <a:p>
+            <a:pPr lvl="1"/>
+            <a:r>
+              <a:rPr lang="en-US" sz="1400" dirty="0"/>
+              <a:t>	Search via search input</a:t>
+            </a:r>
+          </a:p>
+          <a:p>
+            <a:pPr lvl="1"/>
+            <a:r>
+              <a:rPr lang="en-US" sz="1400" dirty="0"/>
+              <a:t>	Add , Delete via buttons</a:t>
+            </a:r>
+          </a:p>
+          <a:p>
+            <a:pPr lvl="1"/>
+            <a:r>
+              <a:rPr lang="en-US" sz="1400" dirty="0"/>
+              <a:t>	Edit via right click , click first on selected table want to edit</a:t>
+            </a:r>
+          </a:p>
+          <a:p>
+            <a:pPr lvl="1"/>
+            <a:r>
+              <a:rPr lang="en-US" sz="1400" dirty="0"/>
+              <a:t>Driver Table:</a:t>
+            </a:r>
+          </a:p>
+          <a:p>
+            <a:pPr lvl="1"/>
+            <a:r>
+              <a:rPr lang="en-US" sz="1400" dirty="0"/>
+              <a:t>	Search via search input</a:t>
+            </a:r>
+          </a:p>
+          <a:p>
+            <a:pPr lvl="1"/>
+            <a:r>
+              <a:rPr lang="en-US" sz="1400" dirty="0"/>
+              <a:t>	Add , Delete via buttons</a:t>
+            </a:r>
+          </a:p>
+          <a:p>
+            <a:pPr lvl="1"/>
+            <a:r>
+              <a:rPr lang="en-US" sz="1400" dirty="0"/>
+              <a:t>	Edit via right click , click first on selected table want to edit</a:t>
+            </a:r>
+          </a:p>
+          <a:p>
+            <a:pPr lvl="1"/>
+            <a:endParaRPr lang="en-US" sz="1400" dirty="0"/>
+          </a:p>
+          <a:p>
+            <a:pPr lvl="1"/>
+            <a:r>
+              <a:rPr lang="en-US" sz="1400" dirty="0"/>
+              <a:t>	</a:t>
+            </a:r>
+          </a:p>
+          <a:p>
+            <a:endParaRPr lang="en-US" dirty="0"/>
+          </a:p>
+        </p:txBody>
+      </p:sp>
+    </p:spTree>
+    <p:extLst>
+      <p:ext uri="{BB962C8B-B14F-4D97-AF65-F5344CB8AC3E}">
+        <p14:creationId xmlns:p14="http://schemas.microsoft.com/office/powerpoint/2010/main" val="1801396052"/>
+      </p:ext>
+    </p:extLst>
+  </p:cSld>
+  <p:clrMapOvr>
+    <a:masterClrMapping/>
+  </p:clrMapOvr>
+</p:sld>
+</file>
+
+<file path=ppt/slides/slide7.xml><?xml version="1.0" encoding="utf-8"?>
+<p:sld xmlns:a="http://schemas.openxmlformats.org/drawingml/2006/main" xmlns:r="http://schemas.openxmlformats.org/officeDocument/2006/relationships" xmlns:p="http://schemas.openxmlformats.org/presentationml/2006/main">
+  <p:cSld>
+    <p:spTree>
+      <p:nvGrpSpPr>
+        <p:cNvPr id="1" name="">
+          <a:extLst>
+            <a:ext uri="{FF2B5EF4-FFF2-40B4-BE49-F238E27FC236}">
+              <a16:creationId xmlns:a16="http://schemas.microsoft.com/office/drawing/2014/main" id="{226D64D5-2400-9522-1995-46E84B82A1E6}"/>
+            </a:ext>
+          </a:extLst>
+        </p:cNvPr>
+        <p:cNvGrpSpPr/>
+        <p:nvPr/>
+      </p:nvGrpSpPr>
+      <p:grpSpPr>
+        <a:xfrm>
+          <a:off x="0" y="0"/>
+          <a:ext cx="0" cy="0"/>
+          <a:chOff x="0" y="0"/>
+          <a:chExt cx="0" cy="0"/>
+        </a:xfrm>
+      </p:grpSpPr>
+      <p:sp>
+        <p:nvSpPr>
+          <p:cNvPr id="4" name="TextBox 3">
+            <a:extLst>
+              <a:ext uri="{FF2B5EF4-FFF2-40B4-BE49-F238E27FC236}">
+                <a16:creationId xmlns:a16="http://schemas.microsoft.com/office/drawing/2014/main" id="{366C9C96-7A25-548D-809F-D6D8D94BC124}"/>
+              </a:ext>
+            </a:extLst>
+          </p:cNvPr>
+          <p:cNvSpPr txBox="1"/>
+          <p:nvPr/>
+        </p:nvSpPr>
+        <p:spPr>
+          <a:xfrm>
+            <a:off x="960120" y="987552"/>
+            <a:ext cx="10506456" cy="1138773"/>
+          </a:xfrm>
+          <a:prstGeom prst="rect">
+            <a:avLst/>
+          </a:prstGeom>
+          <a:noFill/>
+        </p:spPr>
+        <p:txBody>
+          <a:bodyPr wrap="square" rtlCol="0">
+            <a:spAutoFit/>
+          </a:bodyPr>
+          <a:lstStyle/>
+          <a:p>
+            <a:r>
+              <a:rPr lang="en-US" b="1" dirty="0"/>
+              <a:t>Logs</a:t>
+            </a:r>
+          </a:p>
+          <a:p>
+            <a:pPr lvl="1"/>
+            <a:r>
+              <a:rPr lang="en-US" sz="1400" dirty="0"/>
+              <a:t>Display activity log straight forward self explanatory</a:t>
+            </a:r>
+          </a:p>
+          <a:p>
+            <a:br>
+              <a:rPr lang="en-US" dirty="0"/>
+            </a:br>
+            <a:endParaRPr lang="en-US" dirty="0"/>
+          </a:p>
+        </p:txBody>
+      </p:sp>
+      <p:sp>
+        <p:nvSpPr>
+          <p:cNvPr id="2" name="TextBox 1">
+            <a:extLst>
+              <a:ext uri="{FF2B5EF4-FFF2-40B4-BE49-F238E27FC236}">
+                <a16:creationId xmlns:a16="http://schemas.microsoft.com/office/drawing/2014/main" id="{682A9B1B-CAD5-733D-685B-8A35A927FFFB}"/>
+              </a:ext>
+            </a:extLst>
+          </p:cNvPr>
+          <p:cNvSpPr txBox="1"/>
+          <p:nvPr/>
+        </p:nvSpPr>
+        <p:spPr>
+          <a:xfrm>
+            <a:off x="960120" y="1963722"/>
+            <a:ext cx="10506456" cy="2800767"/>
+          </a:xfrm>
+          <a:prstGeom prst="rect">
+            <a:avLst/>
+          </a:prstGeom>
+          <a:noFill/>
+        </p:spPr>
+        <p:txBody>
+          <a:bodyPr wrap="square" rtlCol="0">
+            <a:spAutoFit/>
+          </a:bodyPr>
+          <a:lstStyle/>
+          <a:p>
+            <a:r>
+              <a:rPr lang="en-US" b="1" dirty="0"/>
+              <a:t>Advance</a:t>
+            </a:r>
+          </a:p>
+          <a:p>
+            <a:pPr lvl="1"/>
+            <a:r>
+              <a:rPr lang="en-US" sz="1400" dirty="0"/>
+              <a:t>Driver Violation:</a:t>
+            </a:r>
+          </a:p>
+          <a:p>
+            <a:pPr lvl="1"/>
+            <a:r>
+              <a:rPr lang="en-US" sz="1400" dirty="0"/>
+              <a:t>	Search via search input</a:t>
+            </a:r>
+          </a:p>
+          <a:p>
+            <a:pPr lvl="1"/>
+            <a:r>
+              <a:rPr lang="en-US" sz="1400" dirty="0"/>
+              <a:t>	Add , Delete via buttons</a:t>
+            </a:r>
+          </a:p>
+          <a:p>
+            <a:pPr lvl="1"/>
+            <a:r>
+              <a:rPr lang="en-US" sz="1400" dirty="0"/>
+              <a:t>	Edit via right click , click first on selected table want to edit</a:t>
+            </a:r>
+          </a:p>
+          <a:p>
+            <a:pPr lvl="1"/>
+            <a:r>
+              <a:rPr lang="en-US" sz="1400" dirty="0"/>
+              <a:t>Violation Type:</a:t>
+            </a:r>
+          </a:p>
+          <a:p>
+            <a:pPr lvl="1"/>
+            <a:r>
+              <a:rPr lang="en-US" sz="1400" dirty="0"/>
+              <a:t>	Search via search input</a:t>
+            </a:r>
+          </a:p>
+          <a:p>
+            <a:pPr lvl="1"/>
+            <a:r>
+              <a:rPr lang="en-US" sz="1400" dirty="0"/>
+              <a:t>	Add , Delete via buttons</a:t>
+            </a:r>
+          </a:p>
+          <a:p>
+            <a:pPr lvl="1"/>
+            <a:r>
+              <a:rPr lang="en-US" sz="1400" dirty="0"/>
+              <a:t>	Edit via right click , click first on selected table want to edit</a:t>
+            </a:r>
+          </a:p>
+          <a:p>
+            <a:pPr lvl="1"/>
+            <a:endParaRPr lang="en-US" sz="1400" dirty="0"/>
+          </a:p>
+          <a:p>
+            <a:pPr lvl="1"/>
+            <a:r>
+              <a:rPr lang="en-US" sz="1400" dirty="0"/>
+              <a:t>	</a:t>
+            </a:r>
+          </a:p>
+          <a:p>
+            <a:endParaRPr lang="en-US" dirty="0"/>
+          </a:p>
+        </p:txBody>
+      </p:sp>
+      <p:sp>
+        <p:nvSpPr>
+          <p:cNvPr id="3" name="TextBox 2">
+            <a:extLst>
+              <a:ext uri="{FF2B5EF4-FFF2-40B4-BE49-F238E27FC236}">
+                <a16:creationId xmlns:a16="http://schemas.microsoft.com/office/drawing/2014/main" id="{65D2245B-152C-ECD4-3E2F-09E4C3A7716E}"/>
+              </a:ext>
+            </a:extLst>
+          </p:cNvPr>
+          <p:cNvSpPr txBox="1"/>
+          <p:nvPr/>
+        </p:nvSpPr>
+        <p:spPr>
+          <a:xfrm>
+            <a:off x="1030224" y="4340275"/>
+            <a:ext cx="10506456" cy="1292662"/>
+          </a:xfrm>
+          <a:prstGeom prst="rect">
+            <a:avLst/>
+          </a:prstGeom>
+          <a:noFill/>
+        </p:spPr>
+        <p:txBody>
+          <a:bodyPr wrap="square" rtlCol="0">
+            <a:spAutoFit/>
+          </a:bodyPr>
+          <a:lstStyle/>
+          <a:p>
+            <a:r>
+              <a:rPr lang="en-US" b="1" dirty="0"/>
+              <a:t>Settings</a:t>
+            </a:r>
+          </a:p>
+          <a:p>
+            <a:pPr lvl="1"/>
+            <a:r>
+              <a:rPr lang="en-US" sz="1400" dirty="0"/>
+              <a:t>Select Device to use up to 5 device and set proper baud rate on device common (9600): </a:t>
+            </a:r>
+          </a:p>
+          <a:p>
+            <a:pPr lvl="1"/>
+            <a:endParaRPr lang="en-US" sz="1400" dirty="0"/>
+          </a:p>
+          <a:p>
+            <a:pPr lvl="1"/>
+            <a:r>
+              <a:rPr lang="en-US" sz="1400" dirty="0"/>
+              <a:t>	</a:t>
+            </a:r>
+          </a:p>
+          <a:p>
+            <a:endParaRPr lang="en-US" dirty="0"/>
+          </a:p>
+        </p:txBody>
+      </p:sp>
+    </p:spTree>
+    <p:extLst>
+      <p:ext uri="{BB962C8B-B14F-4D97-AF65-F5344CB8AC3E}">
+        <p14:creationId xmlns:p14="http://schemas.microsoft.com/office/powerpoint/2010/main" val="2584356606"/>
+      </p:ext>
+    </p:extLst>
+  </p:cSld>
+  <p:clrMapOvr>
+    <a:masterClrMapping/>
+  </p:clrMapOvr>
+</p:sld>
+</file>
+
+<file path=ppt/slides/slide8.xml><?xml version="1.0" encoding="utf-8"?>
+<p:sld xmlns:a="http://schemas.openxmlformats.org/drawingml/2006/main" xmlns:r="http://schemas.openxmlformats.org/officeDocument/2006/relationships" xmlns:p="http://schemas.openxmlformats.org/presentationml/2006/main">
+  <p:cSld>
+    <p:spTree>
+      <p:nvGrpSpPr>
+        <p:cNvPr id="1" name="">
+          <a:extLst>
+            <a:ext uri="{FF2B5EF4-FFF2-40B4-BE49-F238E27FC236}">
+              <a16:creationId xmlns:a16="http://schemas.microsoft.com/office/drawing/2014/main" id="{4AD8F99D-91AA-EFBD-7BA5-8C92BA67E5B4}"/>
+            </a:ext>
+          </a:extLst>
+        </p:cNvPr>
+        <p:cNvGrpSpPr/>
+        <p:nvPr/>
+      </p:nvGrpSpPr>
+      <p:grpSpPr>
+        <a:xfrm>
+          <a:off x="0" y="0"/>
+          <a:ext cx="0" cy="0"/>
+          <a:chOff x="0" y="0"/>
+          <a:chExt cx="0" cy="0"/>
+        </a:xfrm>
+      </p:grpSpPr>
+      <p:sp>
+        <p:nvSpPr>
+          <p:cNvPr id="4" name="TextBox 3">
+            <a:extLst>
+              <a:ext uri="{FF2B5EF4-FFF2-40B4-BE49-F238E27FC236}">
+                <a16:creationId xmlns:a16="http://schemas.microsoft.com/office/drawing/2014/main" id="{DC7FAC94-69C2-3050-6F58-5B6355ED09D3}"/>
+              </a:ext>
+            </a:extLst>
+          </p:cNvPr>
+          <p:cNvSpPr txBox="1"/>
+          <p:nvPr/>
+        </p:nvSpPr>
+        <p:spPr>
+          <a:xfrm>
+            <a:off x="506341" y="987552"/>
+            <a:ext cx="10506456" cy="1877437"/>
+          </a:xfrm>
+          <a:prstGeom prst="rect">
+            <a:avLst/>
+          </a:prstGeom>
+          <a:noFill/>
+        </p:spPr>
+        <p:txBody>
+          <a:bodyPr wrap="square" rtlCol="0">
+            <a:spAutoFit/>
+          </a:bodyPr>
+          <a:lstStyle/>
+          <a:p>
+            <a:r>
+              <a:rPr lang="en-US" b="1" dirty="0"/>
+              <a:t>DATABASE STRUCTURE SUMMARY</a:t>
+            </a:r>
+          </a:p>
+          <a:p>
+            <a:pPr lvl="1"/>
+            <a:r>
+              <a:rPr lang="en-US" sz="1400" dirty="0"/>
+              <a:t>Your DB contains </a:t>
+            </a:r>
+            <a:r>
+              <a:rPr lang="en-US" sz="1400" b="1" dirty="0"/>
+              <a:t>5 tables</a:t>
+            </a:r>
+            <a:r>
+              <a:rPr lang="en-US" sz="1400" dirty="0"/>
+              <a:t>:</a:t>
+            </a:r>
+          </a:p>
+          <a:p>
+            <a:pPr lvl="1"/>
+            <a:r>
+              <a:rPr lang="en-US" sz="1400" b="1" dirty="0"/>
+              <a:t>drivers</a:t>
+            </a:r>
+            <a:endParaRPr lang="en-US" sz="1400" dirty="0"/>
+          </a:p>
+          <a:p>
+            <a:pPr lvl="1"/>
+            <a:r>
+              <a:rPr lang="en-US" sz="1400" b="1" dirty="0" err="1"/>
+              <a:t>system_users</a:t>
+            </a:r>
+            <a:endParaRPr lang="en-US" sz="1400" dirty="0"/>
+          </a:p>
+          <a:p>
+            <a:pPr lvl="1"/>
+            <a:r>
+              <a:rPr lang="en-US" sz="1400" b="1" dirty="0"/>
+              <a:t>violations</a:t>
+            </a:r>
+            <a:endParaRPr lang="en-US" sz="1400" dirty="0"/>
+          </a:p>
+          <a:p>
+            <a:pPr lvl="1"/>
+            <a:r>
+              <a:rPr lang="en-US" sz="1400" b="1" dirty="0" err="1"/>
+              <a:t>violations_type</a:t>
+            </a:r>
+            <a:endParaRPr lang="en-US" sz="1400" dirty="0"/>
+          </a:p>
+          <a:p>
+            <a:pPr lvl="1"/>
+            <a:r>
+              <a:rPr lang="en-US" sz="1400" b="1" dirty="0"/>
+              <a:t>Comports</a:t>
+            </a:r>
+          </a:p>
+          <a:p>
+            <a:pPr lvl="1"/>
+            <a:endParaRPr lang="en-US" sz="1400" dirty="0"/>
+          </a:p>
+        </p:txBody>
+      </p:sp>
+      <p:sp>
+        <p:nvSpPr>
+          <p:cNvPr id="5" name="TextBox 4">
+            <a:extLst>
+              <a:ext uri="{FF2B5EF4-FFF2-40B4-BE49-F238E27FC236}">
+                <a16:creationId xmlns:a16="http://schemas.microsoft.com/office/drawing/2014/main" id="{55F0CFE5-C7E2-1E53-F2C6-A734F2784D21}"/>
+              </a:ext>
+            </a:extLst>
+          </p:cNvPr>
+          <p:cNvSpPr txBox="1"/>
+          <p:nvPr/>
+        </p:nvSpPr>
+        <p:spPr>
+          <a:xfrm>
+            <a:off x="506341" y="2864989"/>
+            <a:ext cx="10506456" cy="1500411"/>
+          </a:xfrm>
+          <a:prstGeom prst="rect">
+            <a:avLst/>
+          </a:prstGeom>
+          <a:noFill/>
+        </p:spPr>
+        <p:txBody>
+          <a:bodyPr wrap="square" rtlCol="0">
+            <a:spAutoFit/>
+          </a:bodyPr>
+          <a:lstStyle/>
+          <a:p>
+            <a:r>
+              <a:rPr lang="en-US" dirty="0"/>
+              <a:t>TABLE: </a:t>
+            </a:r>
+            <a:r>
+              <a:rPr lang="en-US" b="1" dirty="0"/>
+              <a:t>drivers</a:t>
+            </a:r>
+            <a:endParaRPr lang="en-US" sz="1400" dirty="0"/>
+          </a:p>
+          <a:p>
+            <a:pPr lvl="1"/>
+            <a:r>
+              <a:rPr lang="en-US" sz="1050" dirty="0">
+                <a:latin typeface="Monospac821 BT" panose="020B0609020202020204" pitchFamily="49" charset="0"/>
+              </a:rPr>
+              <a:t>Column	Type			Meaning</a:t>
+            </a:r>
+          </a:p>
+          <a:p>
+            <a:pPr lvl="1"/>
+            <a:r>
+              <a:rPr lang="en-US" sz="1050" dirty="0">
+                <a:latin typeface="Monospac821 BT" panose="020B0609020202020204" pitchFamily="49" charset="0"/>
+              </a:rPr>
+              <a:t>id		INTEGER PK AUTOINCREMENT	Internal primary key</a:t>
+            </a:r>
+          </a:p>
+          <a:p>
+            <a:pPr lvl="1"/>
+            <a:r>
+              <a:rPr lang="en-US" sz="1050" dirty="0" err="1">
+                <a:latin typeface="Monospac821 BT" panose="020B0609020202020204" pitchFamily="49" charset="0"/>
+              </a:rPr>
+              <a:t>driver_id</a:t>
+            </a:r>
+            <a:r>
+              <a:rPr lang="en-US" sz="1050" dirty="0">
+                <a:latin typeface="Monospac821 BT" panose="020B0609020202020204" pitchFamily="49" charset="0"/>
+              </a:rPr>
+              <a:t>	TEXT UNIQUE			Your own assigned driver code (e.g. "DR-001")</a:t>
+            </a:r>
+          </a:p>
+          <a:p>
+            <a:pPr lvl="1"/>
+            <a:r>
+              <a:rPr lang="en-US" sz="1050" dirty="0" err="1">
+                <a:latin typeface="Monospac821 BT" panose="020B0609020202020204" pitchFamily="49" charset="0"/>
+              </a:rPr>
+              <a:t>rfid_serial</a:t>
+            </a:r>
+            <a:r>
+              <a:rPr lang="en-US" sz="1050" dirty="0">
+                <a:latin typeface="Monospac821 BT" panose="020B0609020202020204" pitchFamily="49" charset="0"/>
+              </a:rPr>
+              <a:t>	TEXT UNIQUE			RFID card serial assigned to driver</a:t>
+            </a:r>
+          </a:p>
+          <a:p>
+            <a:pPr lvl="1"/>
+            <a:r>
+              <a:rPr lang="en-US" sz="1050" dirty="0" err="1">
+                <a:latin typeface="Monospac821 BT" panose="020B0609020202020204" pitchFamily="49" charset="0"/>
+              </a:rPr>
+              <a:t>full_name</a:t>
+            </a:r>
+            <a:r>
+              <a:rPr lang="en-US" sz="1050" dirty="0">
+                <a:latin typeface="Monospac821 BT" panose="020B0609020202020204" pitchFamily="49" charset="0"/>
+              </a:rPr>
+              <a:t>	TEXT			Driver’s complete name</a:t>
+            </a:r>
+          </a:p>
+          <a:p>
+            <a:pPr lvl="1"/>
+            <a:r>
+              <a:rPr lang="en-US" sz="1050" dirty="0" err="1">
+                <a:latin typeface="Monospac821 BT" panose="020B0609020202020204" pitchFamily="49" charset="0"/>
+              </a:rPr>
+              <a:t>created_at</a:t>
+            </a:r>
+            <a:r>
+              <a:rPr lang="en-US" sz="1050" dirty="0">
+                <a:latin typeface="Monospac821 BT" panose="020B0609020202020204" pitchFamily="49" charset="0"/>
+              </a:rPr>
+              <a:t>	TEXT			Auto timestamp when added (</a:t>
+            </a:r>
+            <a:r>
+              <a:rPr lang="en-US" sz="1050" dirty="0" err="1">
+                <a:latin typeface="Monospac821 BT" panose="020B0609020202020204" pitchFamily="49" charset="0"/>
+              </a:rPr>
+              <a:t>localtime</a:t>
+            </a:r>
+            <a:r>
+              <a:rPr lang="en-US" sz="1050" dirty="0">
+                <a:latin typeface="Monospac821 BT" panose="020B0609020202020204" pitchFamily="49" charset="0"/>
+              </a:rPr>
+              <a:t>)</a:t>
+            </a:r>
+          </a:p>
+          <a:p>
+            <a:pPr lvl="1"/>
+            <a:r>
+              <a:rPr lang="en-US" sz="1050" dirty="0">
+                <a:latin typeface="Monospac821 BT" panose="020B0609020202020204" pitchFamily="49" charset="0"/>
+              </a:rPr>
+              <a:t>vehicle	TEXT			Vehicle </a:t>
+            </a:r>
+            <a:r>
+              <a:rPr lang="en-US" sz="1050" dirty="0" err="1">
+                <a:latin typeface="Monospac821 BT" panose="020B0609020202020204" pitchFamily="49" charset="0"/>
+              </a:rPr>
+              <a:t>descrip</a:t>
+            </a:r>
+            <a:endParaRPr lang="en-US" sz="1050" dirty="0">
+              <a:latin typeface="Monospac821 BT" panose="020B0609020202020204" pitchFamily="49" charset="0"/>
+            </a:endParaRPr>
+          </a:p>
+        </p:txBody>
+      </p:sp>
+      <p:sp>
+        <p:nvSpPr>
+          <p:cNvPr id="20" name="TextBox 19">
+            <a:extLst>
+              <a:ext uri="{FF2B5EF4-FFF2-40B4-BE49-F238E27FC236}">
+                <a16:creationId xmlns:a16="http://schemas.microsoft.com/office/drawing/2014/main" id="{E0523704-E7F5-24A2-564B-7884083A3A8E}"/>
+              </a:ext>
+            </a:extLst>
+          </p:cNvPr>
+          <p:cNvSpPr txBox="1"/>
+          <p:nvPr/>
+        </p:nvSpPr>
+        <p:spPr>
+          <a:xfrm>
+            <a:off x="506341" y="4647782"/>
+            <a:ext cx="10506456" cy="1338828"/>
+          </a:xfrm>
+          <a:prstGeom prst="rect">
+            <a:avLst/>
+          </a:prstGeom>
+          <a:noFill/>
+        </p:spPr>
+        <p:txBody>
+          <a:bodyPr wrap="square" rtlCol="0">
+            <a:spAutoFit/>
+          </a:bodyPr>
+          <a:lstStyle/>
+          <a:p>
+            <a:r>
+              <a:rPr lang="en-US" dirty="0"/>
+              <a:t>TABLE: </a:t>
+            </a:r>
+            <a:r>
+              <a:rPr lang="en-US" b="1" dirty="0" err="1"/>
+              <a:t>system_users</a:t>
+            </a:r>
+            <a:endParaRPr lang="en-US" b="1" dirty="0"/>
+          </a:p>
+          <a:p>
+            <a:pPr lvl="1"/>
+            <a:r>
+              <a:rPr lang="en-US" sz="1050" dirty="0">
+                <a:latin typeface="Monospac821 BT" panose="020B0609020202020204" pitchFamily="49" charset="0"/>
+              </a:rPr>
+              <a:t>Column	Type			Meaning</a:t>
+            </a:r>
+          </a:p>
+          <a:p>
+            <a:pPr lvl="1"/>
+            <a:r>
+              <a:rPr lang="en-US" sz="1050" dirty="0">
+                <a:latin typeface="Monospac821 BT" panose="020B0609020202020204" pitchFamily="49" charset="0"/>
+              </a:rPr>
+              <a:t>id		INTEGER PK AUTOINCREMENT	Internal ID</a:t>
+            </a:r>
+          </a:p>
+          <a:p>
+            <a:pPr lvl="1"/>
+            <a:r>
+              <a:rPr lang="en-US" sz="1050" dirty="0" err="1">
+                <a:latin typeface="Monospac821 BT" panose="020B0609020202020204" pitchFamily="49" charset="0"/>
+              </a:rPr>
+              <a:t>full_name</a:t>
+            </a:r>
+            <a:r>
+              <a:rPr lang="en-US" sz="1050" dirty="0">
+                <a:latin typeface="Monospac821 BT" panose="020B0609020202020204" pitchFamily="49" charset="0"/>
+              </a:rPr>
+              <a:t>	TEXT			Person’s full name</a:t>
+            </a:r>
+          </a:p>
+          <a:p>
+            <a:pPr lvl="1"/>
+            <a:r>
+              <a:rPr lang="en-US" sz="1050" dirty="0" err="1">
+                <a:latin typeface="Monospac821 BT" panose="020B0609020202020204" pitchFamily="49" charset="0"/>
+              </a:rPr>
+              <a:t>user_name</a:t>
+            </a:r>
+            <a:r>
+              <a:rPr lang="en-US" sz="1050" dirty="0">
+                <a:latin typeface="Monospac821 BT" panose="020B0609020202020204" pitchFamily="49" charset="0"/>
+              </a:rPr>
+              <a:t>	TEXT UNIQUE			Login username</a:t>
+            </a:r>
+          </a:p>
+          <a:p>
+            <a:pPr lvl="1"/>
+            <a:r>
+              <a:rPr lang="en-US" sz="1050" dirty="0">
+                <a:latin typeface="Monospac821 BT" panose="020B0609020202020204" pitchFamily="49" charset="0"/>
+              </a:rPr>
+              <a:t>password	TEXT (SHA-256 hash)		Hashed password, NOT plaintext</a:t>
+            </a:r>
+          </a:p>
+          <a:p>
+            <a:pPr lvl="1"/>
+            <a:r>
+              <a:rPr lang="en-US" sz="1050" dirty="0" err="1">
+                <a:latin typeface="Monospac821 BT" panose="020B0609020202020204" pitchFamily="49" charset="0"/>
+              </a:rPr>
+              <a:t>user_type</a:t>
+            </a:r>
+            <a:r>
+              <a:rPr lang="en-US" sz="1050" dirty="0">
+                <a:latin typeface="Monospac821 BT" panose="020B0609020202020204" pitchFamily="49" charset="0"/>
+              </a:rPr>
+              <a:t>	TEXT			ADMIN or USER/OPERATOR</a:t>
+            </a:r>
+          </a:p>
+        </p:txBody>
+      </p:sp>
+    </p:spTree>
+    <p:extLst>
+      <p:ext uri="{BB962C8B-B14F-4D97-AF65-F5344CB8AC3E}">
+        <p14:creationId xmlns:p14="http://schemas.microsoft.com/office/powerpoint/2010/main" val="1275783912"/>
+      </p:ext>
+    </p:extLst>
+  </p:cSld>
+  <p:clrMapOvr>
+    <a:masterClrMapping/>
+  </p:clrMapOvr>
+</p:sld>
+</file>
+
+<file path=ppt/slides/slide9.xml><?xml version="1.0" encoding="utf-8"?>
+<p:sld xmlns:a="http://schemas.openxmlformats.org/drawingml/2006/main" xmlns:r="http://schemas.openxmlformats.org/officeDocument/2006/relationships" xmlns:p="http://schemas.openxmlformats.org/presentationml/2006/main">
+  <p:cSld>
+    <p:spTree>
+      <p:nvGrpSpPr>
+        <p:cNvPr id="1" name="">
+          <a:extLst>
+            <a:ext uri="{FF2B5EF4-FFF2-40B4-BE49-F238E27FC236}">
+              <a16:creationId xmlns:a16="http://schemas.microsoft.com/office/drawing/2014/main" id="{48BD802B-A0B0-BF84-8CE2-DED1D7E7E7B3}"/>
+            </a:ext>
+          </a:extLst>
+        </p:cNvPr>
+        <p:cNvGrpSpPr/>
+        <p:nvPr/>
+      </p:nvGrpSpPr>
+      <p:grpSpPr>
+        <a:xfrm>
+          <a:off x="0" y="0"/>
+          <a:ext cx="0" cy="0"/>
+          <a:chOff x="0" y="0"/>
+          <a:chExt cx="0" cy="0"/>
+        </a:xfrm>
+      </p:grpSpPr>
+      <p:sp>
+        <p:nvSpPr>
+          <p:cNvPr id="5" name="TextBox 4">
+            <a:extLst>
+              <a:ext uri="{FF2B5EF4-FFF2-40B4-BE49-F238E27FC236}">
+                <a16:creationId xmlns:a16="http://schemas.microsoft.com/office/drawing/2014/main" id="{06706E05-19A5-2796-076B-9FA947ADCD0C}"/>
+              </a:ext>
+            </a:extLst>
+          </p:cNvPr>
+          <p:cNvSpPr txBox="1"/>
+          <p:nvPr/>
+        </p:nvSpPr>
+        <p:spPr>
+          <a:xfrm>
+            <a:off x="506341" y="285694"/>
+            <a:ext cx="10506456" cy="2146742"/>
+          </a:xfrm>
+          <a:prstGeom prst="rect">
+            <a:avLst/>
+          </a:prstGeom>
+          <a:noFill/>
+        </p:spPr>
+        <p:txBody>
+          <a:bodyPr wrap="square" rtlCol="0">
+            <a:spAutoFit/>
+          </a:bodyPr>
+          <a:lstStyle/>
+          <a:p>
+            <a:r>
+              <a:rPr lang="en-US" dirty="0"/>
+              <a:t>TABLE: </a:t>
+            </a:r>
+            <a:r>
+              <a:rPr lang="en-US" b="1" dirty="0"/>
+              <a:t>violations</a:t>
+            </a:r>
+          </a:p>
+          <a:p>
+            <a:r>
+              <a:rPr lang="en-US" sz="1050" dirty="0">
+                <a:latin typeface="Monospac821 BT" panose="020B0609020202020204" pitchFamily="49" charset="0"/>
+              </a:rPr>
+              <a:t>Column	Type			Meaning</a:t>
+            </a:r>
+          </a:p>
+          <a:p>
+            <a:r>
+              <a:rPr lang="en-US" sz="1050" dirty="0">
+                <a:latin typeface="Monospac821 BT" panose="020B0609020202020204" pitchFamily="49" charset="0"/>
+              </a:rPr>
+              <a:t>id	INTEGER PK AUTOINCREMENT	Violation number</a:t>
+            </a:r>
+          </a:p>
+          <a:p>
+            <a:r>
+              <a:rPr lang="en-US" sz="1050" dirty="0" err="1">
+                <a:latin typeface="Monospac821 BT" panose="020B0609020202020204" pitchFamily="49" charset="0"/>
+              </a:rPr>
+              <a:t>driver_name</a:t>
+            </a:r>
+            <a:r>
+              <a:rPr lang="en-US" sz="1050" dirty="0">
+                <a:latin typeface="Monospac821 BT" panose="020B0609020202020204" pitchFamily="49" charset="0"/>
+              </a:rPr>
+              <a:t>	TEXT			Driver full name (duplicate for convenience)</a:t>
+            </a:r>
+          </a:p>
+          <a:p>
+            <a:r>
+              <a:rPr lang="en-US" sz="1050" dirty="0" err="1">
+                <a:latin typeface="Monospac821 BT" panose="020B0609020202020204" pitchFamily="49" charset="0"/>
+              </a:rPr>
+              <a:t>driver_id</a:t>
+            </a:r>
+            <a:r>
+              <a:rPr lang="en-US" sz="1050" dirty="0">
+                <a:latin typeface="Monospac821 BT" panose="020B0609020202020204" pitchFamily="49" charset="0"/>
+              </a:rPr>
+              <a:t>	TEXT			Links to </a:t>
+            </a:r>
+            <a:r>
+              <a:rPr lang="en-US" sz="1050" dirty="0" err="1">
+                <a:latin typeface="Monospac821 BT" panose="020B0609020202020204" pitchFamily="49" charset="0"/>
+              </a:rPr>
+              <a:t>drivers.driver_id</a:t>
+            </a:r>
+            <a:endParaRPr lang="en-US" sz="1050" dirty="0">
+              <a:latin typeface="Monospac821 BT" panose="020B0609020202020204" pitchFamily="49" charset="0"/>
+            </a:endParaRPr>
+          </a:p>
+          <a:p>
+            <a:r>
+              <a:rPr lang="en-US" sz="1050" dirty="0" err="1">
+                <a:latin typeface="Monospac821 BT" panose="020B0609020202020204" pitchFamily="49" charset="0"/>
+              </a:rPr>
+              <a:t>rfid_serial</a:t>
+            </a:r>
+            <a:r>
+              <a:rPr lang="en-US" sz="1050" dirty="0">
+                <a:latin typeface="Monospac821 BT" panose="020B0609020202020204" pitchFamily="49" charset="0"/>
+              </a:rPr>
+              <a:t>	TEXT			Again duplicated for fast lookup</a:t>
+            </a:r>
+          </a:p>
+          <a:p>
+            <a:r>
+              <a:rPr lang="en-US" sz="1050" dirty="0">
+                <a:latin typeface="Monospac821 BT" panose="020B0609020202020204" pitchFamily="49" charset="0"/>
+              </a:rPr>
+              <a:t>violation	TEXT			Type/description of violation</a:t>
+            </a:r>
+          </a:p>
+          <a:p>
+            <a:r>
+              <a:rPr lang="en-US" sz="1050" dirty="0">
+                <a:latin typeface="Monospac821 BT" panose="020B0609020202020204" pitchFamily="49" charset="0"/>
+              </a:rPr>
+              <a:t>vehicle	TEXT			Vehicle involved</a:t>
+            </a:r>
+          </a:p>
+          <a:p>
+            <a:r>
+              <a:rPr lang="en-US" sz="1050" dirty="0">
+                <a:latin typeface="Monospac821 BT" panose="020B0609020202020204" pitchFamily="49" charset="0"/>
+              </a:rPr>
+              <a:t>date	TEXT			When the violation happened</a:t>
+            </a:r>
+          </a:p>
+          <a:p>
+            <a:r>
+              <a:rPr lang="en-US" sz="1050" dirty="0">
+                <a:latin typeface="Monospac821 BT" panose="020B0609020202020204" pitchFamily="49" charset="0"/>
+              </a:rPr>
+              <a:t>amount	REAL			Fine amount</a:t>
+            </a:r>
+          </a:p>
+          <a:p>
+            <a:r>
+              <a:rPr lang="en-US" sz="1050" dirty="0" err="1">
+                <a:latin typeface="Monospac821 BT" panose="020B0609020202020204" pitchFamily="49" charset="0"/>
+              </a:rPr>
+              <a:t>due_date</a:t>
+            </a:r>
+            <a:r>
+              <a:rPr lang="en-US" sz="1050" dirty="0">
+                <a:latin typeface="Monospac821 BT" panose="020B0609020202020204" pitchFamily="49" charset="0"/>
+              </a:rPr>
+              <a:t>	TEXT			Payment deadline</a:t>
+            </a:r>
+          </a:p>
+          <a:p>
+            <a:r>
+              <a:rPr lang="en-US" sz="1050" dirty="0">
+                <a:latin typeface="Monospac821 BT" panose="020B0609020202020204" pitchFamily="49" charset="0"/>
+              </a:rPr>
+              <a:t>paid	TEXT		‘	paid' or '</a:t>
+            </a:r>
+            <a:r>
+              <a:rPr lang="en-US" sz="1050" dirty="0" err="1">
+                <a:latin typeface="Monospac821 BT" panose="020B0609020202020204" pitchFamily="49" charset="0"/>
+              </a:rPr>
+              <a:t>unpa</a:t>
+            </a:r>
+            <a:endParaRPr lang="en-US" sz="1050" dirty="0">
+              <a:latin typeface="Monospac821 BT" panose="020B0609020202020204" pitchFamily="49" charset="0"/>
+            </a:endParaRPr>
+          </a:p>
+        </p:txBody>
+      </p:sp>
+      <p:sp>
+        <p:nvSpPr>
+          <p:cNvPr id="2" name="TextBox 1">
+            <a:extLst>
+              <a:ext uri="{FF2B5EF4-FFF2-40B4-BE49-F238E27FC236}">
+                <a16:creationId xmlns:a16="http://schemas.microsoft.com/office/drawing/2014/main" id="{788FCB1D-3D94-3916-D58D-6C6D60A18B4F}"/>
+              </a:ext>
+            </a:extLst>
+          </p:cNvPr>
+          <p:cNvSpPr txBox="1"/>
+          <p:nvPr/>
+        </p:nvSpPr>
+        <p:spPr>
+          <a:xfrm>
+            <a:off x="506341" y="2759586"/>
+            <a:ext cx="10506456" cy="1015663"/>
+          </a:xfrm>
+          <a:prstGeom prst="rect">
+            <a:avLst/>
+          </a:prstGeom>
+          <a:noFill/>
+        </p:spPr>
+        <p:txBody>
+          <a:bodyPr wrap="square" rtlCol="0">
+            <a:spAutoFit/>
+          </a:bodyPr>
+          <a:lstStyle/>
+          <a:p>
+            <a:r>
+              <a:rPr lang="en-US" dirty="0"/>
+              <a:t>TABLE: </a:t>
+            </a:r>
+            <a:r>
+              <a:rPr lang="en-US" b="1" dirty="0" err="1"/>
+              <a:t>violations_type</a:t>
+            </a:r>
+            <a:endParaRPr lang="en-US" b="1" dirty="0"/>
+          </a:p>
+          <a:p>
+            <a:r>
+              <a:rPr lang="en-US" sz="1050" dirty="0">
+                <a:latin typeface="Monospac821 BT" panose="020B0609020202020204" pitchFamily="49" charset="0"/>
+              </a:rPr>
+              <a:t>Column		Type			Meaning</a:t>
+            </a:r>
+          </a:p>
+          <a:p>
+            <a:r>
+              <a:rPr lang="en-US" sz="1050" dirty="0">
+                <a:latin typeface="Monospac821 BT" panose="020B0609020202020204" pitchFamily="49" charset="0"/>
+              </a:rPr>
+              <a:t>id		INTEGER PK AUTOINCREMENT	Internal ID</a:t>
+            </a:r>
+          </a:p>
+          <a:p>
+            <a:r>
+              <a:rPr lang="en-US" sz="1050" dirty="0" err="1">
+                <a:latin typeface="Monospac821 BT" panose="020B0609020202020204" pitchFamily="49" charset="0"/>
+              </a:rPr>
+              <a:t>violation_type</a:t>
+            </a:r>
+            <a:r>
+              <a:rPr lang="en-US" sz="1050" dirty="0">
+                <a:latin typeface="Monospac821 BT" panose="020B0609020202020204" pitchFamily="49" charset="0"/>
+              </a:rPr>
+              <a:t>	TEXT UNIQUE			Name of violation (e.g., "No Helmet")</a:t>
+            </a:r>
+          </a:p>
+          <a:p>
+            <a:r>
+              <a:rPr lang="en-US" sz="1050" dirty="0">
+                <a:latin typeface="Monospac821 BT" panose="020B0609020202020204" pitchFamily="49" charset="0"/>
+              </a:rPr>
+              <a:t>amount		REAL			Penalty amount</a:t>
+            </a:r>
+          </a:p>
+        </p:txBody>
+      </p:sp>
+      <p:sp>
+        <p:nvSpPr>
+          <p:cNvPr id="3" name="TextBox 2">
+            <a:extLst>
+              <a:ext uri="{FF2B5EF4-FFF2-40B4-BE49-F238E27FC236}">
+                <a16:creationId xmlns:a16="http://schemas.microsoft.com/office/drawing/2014/main" id="{261484B4-BC37-4CAF-A8B8-EA47B47C61CC}"/>
+              </a:ext>
+            </a:extLst>
+          </p:cNvPr>
+          <p:cNvSpPr txBox="1"/>
+          <p:nvPr/>
+        </p:nvSpPr>
+        <p:spPr>
+          <a:xfrm>
+            <a:off x="506341" y="4102399"/>
+            <a:ext cx="10506456" cy="854080"/>
+          </a:xfrm>
+          <a:prstGeom prst="rect">
+            <a:avLst/>
+          </a:prstGeom>
+          <a:noFill/>
+        </p:spPr>
+        <p:txBody>
+          <a:bodyPr wrap="square" rtlCol="0">
+            <a:spAutoFit/>
+          </a:bodyPr>
+          <a:lstStyle/>
+          <a:p>
+            <a:r>
+              <a:rPr lang="en-US" dirty="0"/>
+              <a:t>TABLE: </a:t>
+            </a:r>
+            <a:r>
+              <a:rPr lang="en-US" b="1" dirty="0"/>
+              <a:t>comports</a:t>
+            </a:r>
+          </a:p>
+          <a:p>
+            <a:r>
+              <a:rPr lang="en-US" sz="1050" dirty="0">
+                <a:latin typeface="Monospac821 BT" panose="020B0609020202020204" pitchFamily="49" charset="0"/>
+              </a:rPr>
+              <a:t>Column	Type		Meaning</a:t>
+            </a:r>
+          </a:p>
+          <a:p>
+            <a:r>
+              <a:rPr lang="en-US" sz="1050" dirty="0">
+                <a:latin typeface="Monospac821 BT" panose="020B0609020202020204" pitchFamily="49" charset="0"/>
+              </a:rPr>
+              <a:t>port	TEXT UNIQUE		COM port (e.g., "COM3")</a:t>
+            </a:r>
+          </a:p>
+          <a:p>
+            <a:r>
+              <a:rPr lang="en-US" sz="1050" dirty="0" err="1">
+                <a:latin typeface="Monospac821 BT" panose="020B0609020202020204" pitchFamily="49" charset="0"/>
+              </a:rPr>
+              <a:t>baudrate</a:t>
+            </a:r>
+            <a:r>
+              <a:rPr lang="en-US" sz="1050" dirty="0">
+                <a:latin typeface="Monospac821 BT" panose="020B0609020202020204" pitchFamily="49" charset="0"/>
+              </a:rPr>
+              <a:t>	TEXT		</a:t>
+            </a:r>
+            <a:r>
+              <a:rPr lang="en-US" sz="1050" dirty="0" err="1">
+                <a:latin typeface="Monospac821 BT" panose="020B0609020202020204" pitchFamily="49" charset="0"/>
+              </a:rPr>
+              <a:t>Baudrate</a:t>
+            </a:r>
+            <a:r>
+              <a:rPr lang="en-US" sz="1050" dirty="0">
+                <a:latin typeface="Monospac821 BT" panose="020B0609020202020204" pitchFamily="49" charset="0"/>
+              </a:rPr>
+              <a:t> used</a:t>
+            </a:r>
+          </a:p>
+        </p:txBody>
+      </p:sp>
+    </p:spTree>
+    <p:extLst>
+      <p:ext uri="{BB962C8B-B14F-4D97-AF65-F5344CB8AC3E}">
+        <p14:creationId xmlns:p14="http://schemas.microsoft.com/office/powerpoint/2010/main" val="1577077731"/>
       </p:ext>
     </p:extLst>
   </p:cSld>
@@ -4056,6 +6583,321 @@
 </a:theme>
 </file>
 
+<file path=ppt/theme/theme2.xml><?xml version="1.0" encoding="utf-8"?>
+<a:theme xmlns:a="http://schemas.openxmlformats.org/drawingml/2006/main" name="Office Theme">
+  <a:themeElements>
+    <a:clrScheme name="Office">
+      <a:dk1>
+        <a:sysClr val="windowText" lastClr="000000"/>
+      </a:dk1>
+      <a:lt1>
+        <a:sysClr val="window" lastClr="FFFFFF"/>
+      </a:lt1>
+      <a:dk2>
+        <a:srgbClr val="0E2841"/>
+      </a:dk2>
+      <a:lt2>
+        <a:srgbClr val="E8E8E8"/>
+      </a:lt2>
+      <a:accent1>
+        <a:srgbClr val="156082"/>
+      </a:accent1>
+      <a:accent2>
+        <a:srgbClr val="E97132"/>
+      </a:accent2>
+      <a:accent3>
+        <a:srgbClr val="196B24"/>
+      </a:accent3>
+      <a:accent4>
+        <a:srgbClr val="0F9ED5"/>
+      </a:accent4>
+      <a:accent5>
+        <a:srgbClr val="A02B93"/>
+      </a:accent5>
+      <a:accent6>
+        <a:srgbClr val="4EA72E"/>
+      </a:accent6>
+      <a:hlink>
+        <a:srgbClr val="467886"/>
+      </a:hlink>
+      <a:folHlink>
+        <a:srgbClr val="96607D"/>
+      </a:folHlink>
+    </a:clrScheme>
+    <a:fontScheme name="Office">
+      <a:majorFont>
+        <a:latin typeface="Aptos Display" panose="02110004020202020204"/>
+        <a:ea typeface=""/>
+        <a:cs typeface=""/>
+        <a:font script="Jpan" typeface="游ゴシック Light"/>
+        <a:font script="Hang" typeface="맑은 고딕"/>
+        <a:font script="Hans" typeface="等线 Light"/>
+        <a:font script="Hant" typeface="新細明體"/>
+        <a:font script="Arab" typeface="Times New Roman"/>
+        <a:font script="Hebr" typeface="Times New Roman"/>
+        <a:font script="Thai" typeface="Angsana New"/>
+        <a:font script="Ethi" typeface="Nyala"/>
+        <a:font script="Beng" typeface="Vrinda"/>
+        <a:font script="Gujr" typeface="Shruti"/>
+        <a:font script="Khmr" typeface="MoolBoran"/>
+        <a:font script="Knda" typeface="Tunga"/>
+        <a:font script="Guru" typeface="Raavi"/>
+        <a:font script="Cans" typeface="Euphemia"/>
+        <a:font script="Cher" typeface="Plantagenet Cherokee"/>
+        <a:font script="Yiii" typeface="Microsoft Yi Baiti"/>
+        <a:font script="Tibt" typeface="Microsoft Himalaya"/>
+        <a:font script="Thaa" typeface="MV Boli"/>
+        <a:font script="Deva" typeface="Mangal"/>
+        <a:font script="Telu" typeface="Gautami"/>
+        <a:font script="Taml" typeface="Latha"/>
+        <a:font script="Syrc" typeface="Estrangelo Edessa"/>
+        <a:font script="Orya" typeface="Kalinga"/>
+        <a:font script="Mlym" typeface="Kartika"/>
+        <a:font script="Laoo" typeface="DokChampa"/>
+        <a:font script="Sinh" typeface="Iskoola Pota"/>
+        <a:font script="Mong" typeface="Mongolian Baiti"/>
+        <a:font script="Viet" typeface="Times New Roman"/>
+        <a:font script="Uigh" typeface="Microsoft Uighur"/>
+        <a:font script="Geor" typeface="Sylfaen"/>
+        <a:font script="Armn" typeface="Arial"/>
+        <a:font script="Bugi" typeface="Leelawadee UI"/>
+        <a:font script="Bopo" typeface="Microsoft JhengHei"/>
+        <a:font script="Java" typeface="Javanese Text"/>
+        <a:font script="Lisu" typeface="Segoe UI"/>
+        <a:font script="Mymr" typeface="Myanmar Text"/>
+        <a:font script="Nkoo" typeface="Ebrima"/>
+        <a:font script="Olck" typeface="Nirmala UI"/>
+        <a:font script="Osma" typeface="Ebrima"/>
+        <a:font script="Phag" typeface="Phagspa"/>
+        <a:font script="Syrn" typeface="Estrangelo Edessa"/>
+        <a:font script="Syrj" typeface="Estrangelo Edessa"/>
+        <a:font script="Syre" typeface="Estrangelo Edessa"/>
+        <a:font script="Sora" typeface="Nirmala UI"/>
+        <a:font script="Tale" typeface="Microsoft Tai Le"/>
+        <a:font script="Talu" typeface="Microsoft New Tai Lue"/>
+        <a:font script="Tfng" typeface="Ebrima"/>
+      </a:majorFont>
+      <a:minorFont>
+        <a:latin typeface="Aptos" panose="02110004020202020204"/>
+        <a:ea typeface=""/>
+        <a:cs typeface=""/>
+        <a:font script="Jpan" typeface="游ゴシック"/>
+        <a:font script="Hang" typeface="맑은 고딕"/>
+        <a:font script="Hans" typeface="等线"/>
+        <a:font script="Hant" typeface="新細明體"/>
+        <a:font script="Arab" typeface="Arial"/>
+        <a:font script="Hebr" typeface="Arial"/>
+        <a:font script="Thai" typeface="Cordia New"/>
+        <a:font script="Ethi" typeface="Nyala"/>
+        <a:font script="Beng" typeface="Vrinda"/>
+        <a:font script="Gujr" typeface="Shruti"/>
+        <a:font script="Khmr" typeface="DaunPenh"/>
+        <a:font script="Knda" typeface="Tunga"/>
+        <a:font script="Guru" typeface="Raavi"/>
+        <a:font script="Cans" typeface="Euphemia"/>
+        <a:font script="Cher" typeface="Plantagenet Cherokee"/>
+        <a:font script="Yiii" typeface="Microsoft Yi Baiti"/>
+        <a:font script="Tibt" typeface="Microsoft Himalaya"/>
+        <a:font script="Thaa" typeface="MV Boli"/>
+        <a:font script="Deva" typeface="Mangal"/>
+        <a:font script="Telu" typeface="Gautami"/>
+        <a:font script="Taml" typeface="Latha"/>
+        <a:font script="Syrc" typeface="Estrangelo Edessa"/>
+        <a:font script="Orya" typeface="Kalinga"/>
+        <a:font script="Mlym" typeface="Kartika"/>
+        <a:font script="Laoo" typeface="DokChampa"/>
+        <a:font script="Sinh" typeface="Iskoola Pota"/>
+        <a:font script="Mong" typeface="Mongolian Baiti"/>
+        <a:font script="Viet" typeface="Arial"/>
+        <a:font script="Uigh" typeface="Microsoft Uighur"/>
+        <a:font script="Geor" typeface="Sylfaen"/>
+        <a:font script="Armn" typeface="Arial"/>
+        <a:font script="Bugi" typeface="Leelawadee UI"/>
+        <a:font script="Bopo" typeface="Microsoft JhengHei"/>
+        <a:font script="Java" typeface="Javanese Text"/>
+        <a:font script="Lisu" typeface="Segoe UI"/>
+        <a:font script="Mymr" typeface="Myanmar Text"/>
+        <a:font script="Nkoo" typeface="Ebrima"/>
+        <a:font script="Olck" typeface="Nirmala UI"/>
+        <a:font script="Osma" typeface="Ebrima"/>
+        <a:font script="Phag" typeface="Phagspa"/>
+        <a:font script="Syrn" typeface="Estrangelo Edessa"/>
+        <a:font script="Syrj" typeface="Estrangelo Edessa"/>
+        <a:font script="Syre" typeface="Estrangelo Edessa"/>
+        <a:font script="Sora" typeface="Nirmala UI"/>
+        <a:font script="Tale" typeface="Microsoft Tai Le"/>
+        <a:font script="Talu" typeface="Microsoft New Tai Lue"/>
+        <a:font script="Tfng" typeface="Ebrima"/>
+      </a:minorFont>
+    </a:fontScheme>
+    <a:fmtScheme name="Office">
+      <a:fillStyleLst>
+        <a:solidFill>
+          <a:schemeClr val="phClr"/>
+        </a:solidFill>
+        <a:gradFill rotWithShape="1">
+          <a:gsLst>
+            <a:gs pos="0">
+              <a:schemeClr val="phClr">
+                <a:lumMod val="110000"/>
+                <a:satMod val="105000"/>
+                <a:tint val="67000"/>
+              </a:schemeClr>
+            </a:gs>
+            <a:gs pos="50000">
+              <a:schemeClr val="phClr">
+                <a:lumMod val="105000"/>
+                <a:satMod val="103000"/>
+                <a:tint val="73000"/>
+              </a:schemeClr>
+            </a:gs>
+            <a:gs pos="100000">
+              <a:schemeClr val="phClr">
+                <a:lumMod val="105000"/>
+                <a:satMod val="109000"/>
+                <a:tint val="81000"/>
+              </a:schemeClr>
+            </a:gs>
+          </a:gsLst>
+          <a:lin ang="5400000" scaled="0"/>
+        </a:gradFill>
+        <a:gradFill rotWithShape="1">
+          <a:gsLst>
+            <a:gs pos="0">
+              <a:schemeClr val="phClr">
+                <a:satMod val="103000"/>
+                <a:lumMod val="102000"/>
+                <a:tint val="94000"/>
+              </a:schemeClr>
+            </a:gs>
+            <a:gs pos="50000">
+              <a:schemeClr val="phClr">
+                <a:satMod val="110000"/>
+                <a:lumMod val="100000"/>
+                <a:shade val="100000"/>
+              </a:schemeClr>
+            </a:gs>
+            <a:gs pos="100000">
+              <a:schemeClr val="phClr">
+                <a:lumMod val="99000"/>
+                <a:satMod val="120000"/>
+                <a:shade val="78000"/>
+              </a:schemeClr>
+            </a:gs>
+          </a:gsLst>
+          <a:lin ang="5400000" scaled="0"/>
+        </a:gradFill>
+      </a:fillStyleLst>
+      <a:lnStyleLst>
+        <a:ln w="12700" cap="flat" cmpd="sng" algn="ctr">
+          <a:solidFill>
+            <a:schemeClr val="phClr"/>
+          </a:solidFill>
+          <a:prstDash val="solid"/>
+          <a:miter lim="800000"/>
+        </a:ln>
+        <a:ln w="19050" cap="flat" cmpd="sng" algn="ctr">
+          <a:solidFill>
+            <a:schemeClr val="phClr"/>
+          </a:solidFill>
+          <a:prstDash val="solid"/>
+          <a:miter lim="800000"/>
+        </a:ln>
+        <a:ln w="25400" cap="flat" cmpd="sng" algn="ctr">
+          <a:solidFill>
+            <a:schemeClr val="phClr"/>
+          </a:solidFill>
+          <a:prstDash val="solid"/>
+          <a:miter lim="800000"/>
+        </a:ln>
+      </a:lnStyleLst>
+      <a:effectStyleLst>
+        <a:effectStyle>
+          <a:effectLst/>
+        </a:effectStyle>
+        <a:effectStyle>
+          <a:effectLst/>
+        </a:effectStyle>
+        <a:effectStyle>
+          <a:effectLst>
+            <a:outerShdw blurRad="57150" dist="19050" dir="5400000" algn="ctr" rotWithShape="0">
+              <a:srgbClr val="000000">
+                <a:alpha val="63000"/>
+              </a:srgbClr>
+            </a:outerShdw>
+          </a:effectLst>
+        </a:effectStyle>
+      </a:effectStyleLst>
+      <a:bgFillStyleLst>
+        <a:solidFill>
+          <a:schemeClr val="phClr"/>
+        </a:solidFill>
+        <a:solidFill>
+          <a:schemeClr val="phClr">
+            <a:tint val="95000"/>
+            <a:satMod val="170000"/>
+          </a:schemeClr>
+        </a:solidFill>
+        <a:gradFill rotWithShape="1">
+          <a:gsLst>
+            <a:gs pos="0">
+              <a:schemeClr val="phClr">
+                <a:tint val="93000"/>
+                <a:satMod val="150000"/>
+                <a:shade val="98000"/>
+                <a:lumMod val="102000"/>
+              </a:schemeClr>
+            </a:gs>
+            <a:gs pos="50000">
+              <a:schemeClr val="phClr">
+                <a:tint val="98000"/>
+                <a:satMod val="130000"/>
+                <a:shade val="90000"/>
+                <a:lumMod val="103000"/>
+              </a:schemeClr>
+            </a:gs>
+            <a:gs pos="100000">
+              <a:schemeClr val="phClr">
+                <a:shade val="63000"/>
+                <a:satMod val="120000"/>
+              </a:schemeClr>
+            </a:gs>
+          </a:gsLst>
+          <a:lin ang="5400000" scaled="0"/>
+        </a:gradFill>
+      </a:bgFillStyleLst>
+    </a:fmtScheme>
+  </a:themeElements>
+  <a:objectDefaults>
+    <a:lnDef>
+      <a:spPr/>
+      <a:bodyPr/>
+      <a:lstStyle/>
+      <a:style>
+        <a:lnRef idx="2">
+          <a:schemeClr val="accent1"/>
+        </a:lnRef>
+        <a:fillRef idx="0">
+          <a:schemeClr val="accent1"/>
+        </a:fillRef>
+        <a:effectRef idx="1">
+          <a:schemeClr val="accent1"/>
+        </a:effectRef>
+        <a:fontRef idx="minor">
+          <a:schemeClr val="tx1"/>
+        </a:fontRef>
+      </a:style>
+    </a:lnDef>
+  </a:objectDefaults>
+  <a:extraClrSchemeLst/>
+  <a:extLst>
+    <a:ext uri="{05A4C25C-085E-4340-85A3-A5531E510DB2}">
+      <thm15:themeFamily xmlns:thm15="http://schemas.microsoft.com/office/thememl/2012/main" name="Office Theme" id="{2E142A2C-CD16-42D6-873A-C26D2A0506FA}" vid="{1BDDFF52-6CD6-40A5-AB3C-68EB2F1E4D0A}"/>
+    </a:ext>
+  </a:extLst>
+</a:theme>
+</file>
+
 <file path=docMetadata/LabelInfo.xml><?xml version="1.0" encoding="utf-8"?>
 <clbl:labelList xmlns:clbl="http://schemas.microsoft.com/office/2020/mipLabelMetadata">
   <clbl:label id="{f9dda1df-3fca-45c7-91be-5629a3733338}" enabled="1" method="Standard" siteId="{ec1ca250-c234-4d56-a76b-7dfb9eee0c46}" contentBits="0" removed="0"/>

</xml_diff>